<commit_message>
Results images: one grayscale slide and one color slide
Co-Authored-By: Claude Sonnet 5.5 <noreply@anthropic.com>
Claude-Session: https://claude.ai/code/session_01T6gEewJ8YaCdmnsfS34RJd
</commit_message>
<xml_diff>
--- a/results/seminar/figs/results_images.pptx
+++ b/results/seminar/figs/results_images.pptx
@@ -8,11 +8,9 @@
     <p:sldId id="256" r:id="rId2"/>
     <p:sldId id="257" r:id="rId3"/>
     <p:sldId id="258" r:id="rId4"/>
-    <p:sldId id="259" r:id="rId5"/>
-    <p:sldId id="260" r:id="rId6"/>
   </p:sldIdLst>
   <p:notesMasterIdLst>
-    <p:notesMasterId r:id="rId7"/>
+    <p:notesMasterId r:id="rId5"/>
   </p:notesMasterIdLst>
   <p:sldSz cx="12192000" cy="6858000"/>
   <p:notesSz cx="6858000" cy="12192000"/>
@@ -724,182 +722,6 @@
 </p:notes>
 </file>
 
-<file path=ppt/notesSlides/notesSlide4.xml><?xml version="1.0" encoding="utf-8"?>
-<p:notes xmlns:a="http://schemas.openxmlformats.org/drawingml/2006/main" xmlns:r="http://schemas.openxmlformats.org/officeDocument/2006/relationships" xmlns:p="http://schemas.openxmlformats.org/presentationml/2006/main">
-  <p:cSld>
-    <p:spTree>
-      <p:nvGrpSpPr>
-        <p:cNvPr id="1" name=""/>
-        <p:cNvGrpSpPr/>
-        <p:nvPr/>
-      </p:nvGrpSpPr>
-      <p:grpSpPr>
-        <a:xfrm>
-          <a:off x="0" y="0"/>
-          <a:ext cx="0" cy="0"/>
-          <a:chOff x="0" y="0"/>
-          <a:chExt cx="0" cy="0"/>
-        </a:xfrm>
-      </p:grpSpPr>
-      <p:sp>
-        <p:nvSpPr>
-          <p:cNvPr id="2" name="Slide Image Placeholder 1"/>
-          <p:cNvSpPr>
-            <a:spLocks noGrp="1" noRot="1" noChangeAspect="1"/>
-          </p:cNvSpPr>
-          <p:nvPr>
-            <p:ph type="sldImg"/>
-          </p:nvPr>
-        </p:nvSpPr>
-        <p:spPr/>
-      </p:sp>
-      <p:sp>
-        <p:nvSpPr>
-          <p:cNvPr id="3" name="Notes Placeholder 2"/>
-          <p:cNvSpPr>
-            <a:spLocks noGrp="1"/>
-          </p:cNvSpPr>
-          <p:nvPr>
-            <p:ph type="body" idx="1"/>
-          </p:nvPr>
-        </p:nvSpPr>
-        <p:spPr/>
-        <p:txBody>
-          <a:bodyPr/>
-          <a:lstStyle/>
-          <a:p>
-            <a:r>
-              <a:rPr lang="en-US" dirty="0"/>
-              <a:t/>
-            </a:r>
-            <a:endParaRPr lang="en-US" dirty="0"/>
-          </a:p>
-        </p:txBody>
-      </p:sp>
-      <p:sp>
-        <p:nvSpPr>
-          <p:cNvPr id="4" name="Slide Number Placeholder 3"/>
-          <p:cNvSpPr>
-            <a:spLocks noGrp="1"/>
-          </p:cNvSpPr>
-          <p:nvPr>
-            <p:ph type="sldNum" sz="quarter" idx="10"/>
-          </p:nvPr>
-        </p:nvSpPr>
-        <p:spPr/>
-        <p:txBody>
-          <a:bodyPr/>
-          <a:lstStyle/>
-          <a:p>
-            <a:fld id="{F7021451-1387-4CA6-816F-3879F97B5CBC}" type="slidenum">
-              <a:rPr lang="en-US"/>
-              <a:t>4</a:t>
-            </a:fld>
-            <a:endParaRPr lang="en-US"/>
-          </a:p>
-        </p:txBody>
-      </p:sp>
-    </p:spTree>
-    <p:extLst>
-      <p:ext uri="{BB962C8B-B14F-4D97-AF65-F5344CB8AC3E}">
-        <p14:creationId xmlns:p14="http://schemas.microsoft.com/office/powerpoint/2010/main" val="1024086991"/>
-      </p:ext>
-    </p:extLst>
-  </p:cSld>
-  <p:clrMapOvr>
-    <a:masterClrMapping/>
-  </p:clrMapOvr>
-</p:notes>
-</file>
-
-<file path=ppt/notesSlides/notesSlide5.xml><?xml version="1.0" encoding="utf-8"?>
-<p:notes xmlns:a="http://schemas.openxmlformats.org/drawingml/2006/main" xmlns:r="http://schemas.openxmlformats.org/officeDocument/2006/relationships" xmlns:p="http://schemas.openxmlformats.org/presentationml/2006/main">
-  <p:cSld>
-    <p:spTree>
-      <p:nvGrpSpPr>
-        <p:cNvPr id="1" name=""/>
-        <p:cNvGrpSpPr/>
-        <p:nvPr/>
-      </p:nvGrpSpPr>
-      <p:grpSpPr>
-        <a:xfrm>
-          <a:off x="0" y="0"/>
-          <a:ext cx="0" cy="0"/>
-          <a:chOff x="0" y="0"/>
-          <a:chExt cx="0" cy="0"/>
-        </a:xfrm>
-      </p:grpSpPr>
-      <p:sp>
-        <p:nvSpPr>
-          <p:cNvPr id="2" name="Slide Image Placeholder 1"/>
-          <p:cNvSpPr>
-            <a:spLocks noGrp="1" noRot="1" noChangeAspect="1"/>
-          </p:cNvSpPr>
-          <p:nvPr>
-            <p:ph type="sldImg"/>
-          </p:nvPr>
-        </p:nvSpPr>
-        <p:spPr/>
-      </p:sp>
-      <p:sp>
-        <p:nvSpPr>
-          <p:cNvPr id="3" name="Notes Placeholder 2"/>
-          <p:cNvSpPr>
-            <a:spLocks noGrp="1"/>
-          </p:cNvSpPr>
-          <p:nvPr>
-            <p:ph type="body" idx="1"/>
-          </p:nvPr>
-        </p:nvSpPr>
-        <p:spPr/>
-        <p:txBody>
-          <a:bodyPr/>
-          <a:lstStyle/>
-          <a:p>
-            <a:r>
-              <a:rPr lang="en-US" dirty="0"/>
-              <a:t/>
-            </a:r>
-            <a:endParaRPr lang="en-US" dirty="0"/>
-          </a:p>
-        </p:txBody>
-      </p:sp>
-      <p:sp>
-        <p:nvSpPr>
-          <p:cNvPr id="4" name="Slide Number Placeholder 3"/>
-          <p:cNvSpPr>
-            <a:spLocks noGrp="1"/>
-          </p:cNvSpPr>
-          <p:nvPr>
-            <p:ph type="sldNum" sz="quarter" idx="10"/>
-          </p:nvPr>
-        </p:nvSpPr>
-        <p:spPr/>
-        <p:txBody>
-          <a:bodyPr/>
-          <a:lstStyle/>
-          <a:p>
-            <a:fld id="{F7021451-1387-4CA6-816F-3879F97B5CBC}" type="slidenum">
-              <a:rPr lang="en-US"/>
-              <a:t>5</a:t>
-            </a:fld>
-            <a:endParaRPr lang="en-US"/>
-          </a:p>
-        </p:txBody>
-      </p:sp>
-    </p:spTree>
-    <p:extLst>
-      <p:ext uri="{BB962C8B-B14F-4D97-AF65-F5344CB8AC3E}">
-        <p14:creationId xmlns:p14="http://schemas.microsoft.com/office/powerpoint/2010/main" val="1024086991"/>
-      </p:ext>
-    </p:extLst>
-  </p:cSld>
-  <p:clrMapOvr>
-    <a:masterClrMapping/>
-  </p:clrMapOvr>
-</p:notes>
-</file>
-
 <file path=ppt/slideLayouts/slideLayout1.xml><?xml version="1.0" encoding="utf-8"?>
 <p:sldLayout xmlns:a="http://schemas.openxmlformats.org/drawingml/2006/main" xmlns:r="http://schemas.openxmlformats.org/officeDocument/2006/relationships" xmlns:p="http://schemas.openxmlformats.org/presentationml/2006/main" preserve="1">
   <p:cSld name="DEFAULT">
@@ -2394,7 +2216,7 @@
                 <a:ea typeface="Cambria" pitchFamily="34" charset="-122"/>
                 <a:cs typeface="Cambria" pitchFamily="34" charset="-120"/>
               </a:rPr>
-              <a:t>Original vs Reconstructed: Grayscale</a:t>
+              <a:t>Reconstruction Results: Grayscale Images</a:t>
             </a:r>
             <a:endParaRPr lang="en-US" sz="2800" dirty="0"/>
           </a:p>
@@ -2427,14 +2249,131 @@
       </p:sp>
       <p:sp>
         <p:nvSpPr>
-          <p:cNvPr id="6" name="Shape 4"/>
-          <p:cNvSpPr/>
-          <p:nvPr/>
-        </p:nvSpPr>
-        <p:spPr>
-          <a:xfrm>
-            <a:off x="457200" y="1371600"/>
-            <a:ext cx="2697480" cy="2697480"/>
+          <p:cNvPr id="6" name="Text 4"/>
+          <p:cNvSpPr/>
+          <p:nvPr/>
+        </p:nvSpPr>
+        <p:spPr>
+          <a:xfrm>
+            <a:off x="411480" y="1417320"/>
+            <a:ext cx="1097280" cy="2331720"/>
+          </a:xfrm>
+          <a:prstGeom prst="rect">
+            <a:avLst/>
+          </a:prstGeom>
+          <a:noFill/>
+          <a:ln/>
+        </p:spPr>
+        <p:txBody>
+          <a:bodyPr wrap="square" lIns="0" tIns="0" rIns="0" bIns="0" rtlCol="0" anchor="ctr"/>
+          <a:lstStyle/>
+          <a:p>
+            <a:pPr algn="ctr" indent="0" marL="0">
+              <a:buNone/>
+            </a:pPr>
+            <a:r>
+              <a:rPr lang="en-US" sz="1500" b="1" dirty="0">
+                <a:solidFill>
+                  <a:srgbClr val="2E2055"/>
+                </a:solidFill>
+                <a:latin typeface="Calibri" pitchFamily="34" charset="0"/>
+                <a:ea typeface="Calibri" pitchFamily="34" charset="-122"/>
+                <a:cs typeface="Calibri" pitchFamily="34" charset="-120"/>
+              </a:rPr>
+              <a:t>Original</a:t>
+            </a:r>
+            <a:endParaRPr lang="en-US" sz="1500" dirty="0"/>
+          </a:p>
+        </p:txBody>
+      </p:sp>
+      <p:sp>
+        <p:nvSpPr>
+          <p:cNvPr id="7" name="Text 5"/>
+          <p:cNvSpPr/>
+          <p:nvPr/>
+        </p:nvSpPr>
+        <p:spPr>
+          <a:xfrm>
+            <a:off x="411480" y="3840480"/>
+            <a:ext cx="1097280" cy="2331720"/>
+          </a:xfrm>
+          <a:prstGeom prst="rect">
+            <a:avLst/>
+          </a:prstGeom>
+          <a:noFill/>
+          <a:ln/>
+        </p:spPr>
+        <p:txBody>
+          <a:bodyPr wrap="square" lIns="0" tIns="0" rIns="0" bIns="0" rtlCol="0" anchor="ctr"/>
+          <a:lstStyle/>
+          <a:p>
+            <a:pPr algn="ctr" indent="0" marL="0">
+              <a:buNone/>
+            </a:pPr>
+            <a:r>
+              <a:rPr lang="en-US" sz="1500" b="1" dirty="0">
+                <a:solidFill>
+                  <a:srgbClr val="2E2055"/>
+                </a:solidFill>
+                <a:latin typeface="Calibri" pitchFamily="34" charset="0"/>
+                <a:ea typeface="Calibri" pitchFamily="34" charset="-122"/>
+                <a:cs typeface="Calibri" pitchFamily="34" charset="-120"/>
+              </a:rPr>
+              <a:t>Reconstructed</a:t>
+            </a:r>
+            <a:endParaRPr lang="en-US" sz="1500" dirty="0"/>
+          </a:p>
+        </p:txBody>
+      </p:sp>
+      <p:sp>
+        <p:nvSpPr>
+          <p:cNvPr id="8" name="Text 6"/>
+          <p:cNvSpPr/>
+          <p:nvPr/>
+        </p:nvSpPr>
+        <p:spPr>
+          <a:xfrm>
+            <a:off x="1600200" y="1078992"/>
+            <a:ext cx="2331720" cy="301752"/>
+          </a:xfrm>
+          <a:prstGeom prst="rect">
+            <a:avLst/>
+          </a:prstGeom>
+          <a:noFill/>
+          <a:ln/>
+        </p:spPr>
+        <p:txBody>
+          <a:bodyPr wrap="square" lIns="0" tIns="0" rIns="0" bIns="0" rtlCol="0" anchor="ctr"/>
+          <a:lstStyle/>
+          <a:p>
+            <a:pPr algn="ctr" indent="0" marL="0">
+              <a:buNone/>
+            </a:pPr>
+            <a:r>
+              <a:rPr lang="en-US" sz="1700" b="1" dirty="0">
+                <a:solidFill>
+                  <a:srgbClr val="2A9D8F"/>
+                </a:solidFill>
+                <a:latin typeface="Calibri" pitchFamily="34" charset="0"/>
+                <a:ea typeface="Calibri" pitchFamily="34" charset="-122"/>
+                <a:cs typeface="Calibri" pitchFamily="34" charset="-120"/>
+              </a:rPr>
+              <a:t>Lena</a:t>
+            </a:r>
+            <a:endParaRPr lang="en-US" sz="1700" dirty="0"/>
+          </a:p>
+        </p:txBody>
+      </p:sp>
+      <p:sp>
+        <p:nvSpPr>
+          <p:cNvPr id="9" name="Shape 7"/>
+          <p:cNvSpPr/>
+          <p:nvPr/>
+        </p:nvSpPr>
+        <p:spPr>
+          <a:xfrm>
+            <a:off x="1600200" y="1417320"/>
+            <a:ext cx="2331720" cy="2331720"/>
           </a:xfrm>
           <a:prstGeom prst="rect">
             <a:avLst/>
@@ -2452,14 +2391,14 @@
       </p:sp>
       <p:sp>
         <p:nvSpPr>
-          <p:cNvPr id="7" name="Text 5"/>
-          <p:cNvSpPr/>
-          <p:nvPr/>
-        </p:nvSpPr>
-        <p:spPr>
-          <a:xfrm>
-            <a:off x="457200" y="1371600"/>
-            <a:ext cx="2697480" cy="2697480"/>
+          <p:cNvPr id="10" name="Text 8"/>
+          <p:cNvSpPr/>
+          <p:nvPr/>
+        </p:nvSpPr>
+        <p:spPr>
+          <a:xfrm>
+            <a:off x="1600200" y="1417320"/>
+            <a:ext cx="2331720" cy="2331720"/>
           </a:xfrm>
           <a:prstGeom prst="rect">
             <a:avLst/>
@@ -2491,14 +2430,14 @@
       </p:sp>
       <p:sp>
         <p:nvSpPr>
-          <p:cNvPr id="8" name="Shape 6"/>
-          <p:cNvSpPr/>
-          <p:nvPr/>
-        </p:nvSpPr>
-        <p:spPr>
-          <a:xfrm>
-            <a:off x="3246120" y="1371600"/>
-            <a:ext cx="2697480" cy="2697480"/>
+          <p:cNvPr id="11" name="Shape 9"/>
+          <p:cNvSpPr/>
+          <p:nvPr/>
+        </p:nvSpPr>
+        <p:spPr>
+          <a:xfrm>
+            <a:off x="1600200" y="3840480"/>
+            <a:ext cx="2331720" cy="2331720"/>
           </a:xfrm>
           <a:prstGeom prst="rect">
             <a:avLst/>
@@ -2516,14 +2455,14 @@
       </p:sp>
       <p:sp>
         <p:nvSpPr>
-          <p:cNvPr id="9" name="Text 7"/>
-          <p:cNvSpPr/>
-          <p:nvPr/>
-        </p:nvSpPr>
-        <p:spPr>
-          <a:xfrm>
-            <a:off x="3246120" y="1371600"/>
-            <a:ext cx="2697480" cy="2697480"/>
+          <p:cNvPr id="12" name="Text 10"/>
+          <p:cNvSpPr/>
+          <p:nvPr/>
+        </p:nvSpPr>
+        <p:spPr>
+          <a:xfrm>
+            <a:off x="1600200" y="3840480"/>
+            <a:ext cx="2331720" cy="2331720"/>
           </a:xfrm>
           <a:prstGeom prst="rect">
             <a:avLst/>
@@ -2555,14 +2494,14 @@
       </p:sp>
       <p:sp>
         <p:nvSpPr>
-          <p:cNvPr id="10" name="Text 8"/>
-          <p:cNvSpPr/>
-          <p:nvPr/>
-        </p:nvSpPr>
-        <p:spPr>
-          <a:xfrm>
-            <a:off x="457200" y="4178808"/>
-            <a:ext cx="5486400" cy="365760"/>
+          <p:cNvPr id="13" name="Text 11"/>
+          <p:cNvSpPr/>
+          <p:nvPr/>
+        </p:nvSpPr>
+        <p:spPr>
+          <a:xfrm>
+            <a:off x="1508760" y="6199632"/>
+            <a:ext cx="2514600" cy="457200"/>
           </a:xfrm>
           <a:prstGeom prst="rect">
             <a:avLst/>
@@ -2578,30 +2517,47 @@
               <a:buNone/>
             </a:pPr>
             <a:r>
-              <a:rPr lang="en-US" sz="2000" b="1" dirty="0">
-                <a:solidFill>
-                  <a:srgbClr val="2E2055"/>
-                </a:solidFill>
-                <a:latin typeface="Calibri" pitchFamily="34" charset="0"/>
-                <a:ea typeface="Calibri" pitchFamily="34" charset="-122"/>
-                <a:cs typeface="Calibri" pitchFamily="34" charset="-120"/>
-              </a:rPr>
-              <a:t>Lena</a:t>
-            </a:r>
-            <a:endParaRPr lang="en-US" sz="2000" dirty="0"/>
-          </a:p>
-        </p:txBody>
-      </p:sp>
-      <p:sp>
-        <p:nvSpPr>
-          <p:cNvPr id="11" name="Text 9"/>
-          <p:cNvSpPr/>
-          <p:nvPr/>
-        </p:nvSpPr>
-        <p:spPr>
-          <a:xfrm>
-            <a:off x="457200" y="4572000"/>
-            <a:ext cx="5486400" cy="365760"/>
+              <a:rPr lang="en-US" sz="1300" b="1" dirty="0">
+                <a:solidFill>
+                  <a:srgbClr val="E0457B"/>
+                </a:solidFill>
+                <a:latin typeface="Calibri" pitchFamily="34" charset="0"/>
+                <a:ea typeface="Calibri" pitchFamily="34" charset="-122"/>
+                <a:cs typeface="Calibri" pitchFamily="34" charset="-120"/>
+              </a:rPr>
+              <a:t>CR = ___</a:t>
+            </a:r>
+            <a:endParaRPr lang="en-US" sz="1300" dirty="0"/>
+          </a:p>
+          <a:p>
+            <a:pPr algn="ctr" indent="0" marL="0">
+              <a:buNone/>
+            </a:pPr>
+            <a:r>
+              <a:rPr lang="en-US" sz="1300" dirty="0">
+                <a:solidFill>
+                  <a:srgbClr val="1F1A33"/>
+                </a:solidFill>
+                <a:latin typeface="Calibri" pitchFamily="34" charset="0"/>
+                <a:ea typeface="Calibri" pitchFamily="34" charset="-122"/>
+                <a:cs typeface="Calibri" pitchFamily="34" charset="-120"/>
+              </a:rPr>
+              <a:t>PSNR 29.67 dB   SSIM 0.8190</a:t>
+            </a:r>
+            <a:endParaRPr lang="en-US" sz="1300" dirty="0"/>
+          </a:p>
+        </p:txBody>
+      </p:sp>
+      <p:sp>
+        <p:nvSpPr>
+          <p:cNvPr id="14" name="Text 12"/>
+          <p:cNvSpPr/>
+          <p:nvPr/>
+        </p:nvSpPr>
+        <p:spPr>
+          <a:xfrm>
+            <a:off x="4069080" y="1078992"/>
+            <a:ext cx="2331720" cy="301752"/>
           </a:xfrm>
           <a:prstGeom prst="rect">
             <a:avLst/>
@@ -2617,44 +2573,30 @@
               <a:buNone/>
             </a:pPr>
             <a:r>
-              <a:rPr lang="en-US" sz="1600" b="1" dirty="0">
-                <a:solidFill>
-                  <a:srgbClr val="E0457B"/>
-                </a:solidFill>
-                <a:latin typeface="Calibri" pitchFamily="34" charset="0"/>
-                <a:ea typeface="Calibri" pitchFamily="34" charset="-122"/>
-                <a:cs typeface="Calibri" pitchFamily="34" charset="-120"/>
-              </a:rPr>
-              <a:t>CR = ___</a:t>
-            </a:r>
-            <a:pPr algn="ctr" indent="0" marL="0">
-              <a:buNone/>
-            </a:pPr>
-            <a:r>
-              <a:rPr lang="en-US" sz="1600" dirty="0">
-                <a:solidFill>
-                  <a:srgbClr val="1F1A33"/>
-                </a:solidFill>
-                <a:latin typeface="Calibri" pitchFamily="34" charset="0"/>
-                <a:ea typeface="Calibri" pitchFamily="34" charset="-122"/>
-                <a:cs typeface="Calibri" pitchFamily="34" charset="-120"/>
-              </a:rPr>
-              <a:t>   |   PSNR = 29.67 dB   |   SSIM = 0.8190</a:t>
-            </a:r>
-            <a:endParaRPr lang="en-US" sz="1600" dirty="0"/>
-          </a:p>
-        </p:txBody>
-      </p:sp>
-      <p:sp>
-        <p:nvSpPr>
-          <p:cNvPr id="12" name="Shape 10"/>
-          <p:cNvSpPr/>
-          <p:nvPr/>
-        </p:nvSpPr>
-        <p:spPr>
-          <a:xfrm>
-            <a:off x="6217920" y="1371600"/>
-            <a:ext cx="2697480" cy="2697480"/>
+              <a:rPr lang="en-US" sz="1700" b="1" dirty="0">
+                <a:solidFill>
+                  <a:srgbClr val="2A9D8F"/>
+                </a:solidFill>
+                <a:latin typeface="Calibri" pitchFamily="34" charset="0"/>
+                <a:ea typeface="Calibri" pitchFamily="34" charset="-122"/>
+                <a:cs typeface="Calibri" pitchFamily="34" charset="-120"/>
+              </a:rPr>
+              <a:t>Boat</a:t>
+            </a:r>
+            <a:endParaRPr lang="en-US" sz="1700" dirty="0"/>
+          </a:p>
+        </p:txBody>
+      </p:sp>
+      <p:sp>
+        <p:nvSpPr>
+          <p:cNvPr id="15" name="Shape 13"/>
+          <p:cNvSpPr/>
+          <p:nvPr/>
+        </p:nvSpPr>
+        <p:spPr>
+          <a:xfrm>
+            <a:off x="4069080" y="1417320"/>
+            <a:ext cx="2331720" cy="2331720"/>
           </a:xfrm>
           <a:prstGeom prst="rect">
             <a:avLst/>
@@ -2672,14 +2614,14 @@
       </p:sp>
       <p:sp>
         <p:nvSpPr>
-          <p:cNvPr id="13" name="Text 11"/>
-          <p:cNvSpPr/>
-          <p:nvPr/>
-        </p:nvSpPr>
-        <p:spPr>
-          <a:xfrm>
-            <a:off x="6217920" y="1371600"/>
-            <a:ext cx="2697480" cy="2697480"/>
+          <p:cNvPr id="16" name="Text 14"/>
+          <p:cNvSpPr/>
+          <p:nvPr/>
+        </p:nvSpPr>
+        <p:spPr>
+          <a:xfrm>
+            <a:off x="4069080" y="1417320"/>
+            <a:ext cx="2331720" cy="2331720"/>
           </a:xfrm>
           <a:prstGeom prst="rect">
             <a:avLst/>
@@ -2711,14 +2653,14 @@
       </p:sp>
       <p:sp>
         <p:nvSpPr>
-          <p:cNvPr id="14" name="Shape 12"/>
-          <p:cNvSpPr/>
-          <p:nvPr/>
-        </p:nvSpPr>
-        <p:spPr>
-          <a:xfrm>
-            <a:off x="9006840" y="1371600"/>
-            <a:ext cx="2697480" cy="2697480"/>
+          <p:cNvPr id="17" name="Shape 15"/>
+          <p:cNvSpPr/>
+          <p:nvPr/>
+        </p:nvSpPr>
+        <p:spPr>
+          <a:xfrm>
+            <a:off x="4069080" y="3840480"/>
+            <a:ext cx="2331720" cy="2331720"/>
           </a:xfrm>
           <a:prstGeom prst="rect">
             <a:avLst/>
@@ -2736,14 +2678,14 @@
       </p:sp>
       <p:sp>
         <p:nvSpPr>
-          <p:cNvPr id="15" name="Text 13"/>
-          <p:cNvSpPr/>
-          <p:nvPr/>
-        </p:nvSpPr>
-        <p:spPr>
-          <a:xfrm>
-            <a:off x="9006840" y="1371600"/>
-            <a:ext cx="2697480" cy="2697480"/>
+          <p:cNvPr id="18" name="Text 16"/>
+          <p:cNvSpPr/>
+          <p:nvPr/>
+        </p:nvSpPr>
+        <p:spPr>
+          <a:xfrm>
+            <a:off x="4069080" y="3840480"/>
+            <a:ext cx="2331720" cy="2331720"/>
           </a:xfrm>
           <a:prstGeom prst="rect">
             <a:avLst/>
@@ -2775,14 +2717,14 @@
       </p:sp>
       <p:sp>
         <p:nvSpPr>
-          <p:cNvPr id="16" name="Text 14"/>
-          <p:cNvSpPr/>
-          <p:nvPr/>
-        </p:nvSpPr>
-        <p:spPr>
-          <a:xfrm>
-            <a:off x="6217920" y="4178808"/>
-            <a:ext cx="5486400" cy="365760"/>
+          <p:cNvPr id="19" name="Text 17"/>
+          <p:cNvSpPr/>
+          <p:nvPr/>
+        </p:nvSpPr>
+        <p:spPr>
+          <a:xfrm>
+            <a:off x="3977640" y="6199632"/>
+            <a:ext cx="2514600" cy="457200"/>
           </a:xfrm>
           <a:prstGeom prst="rect">
             <a:avLst/>
@@ -2798,30 +2740,47 @@
               <a:buNone/>
             </a:pPr>
             <a:r>
-              <a:rPr lang="en-US" sz="2000" b="1" dirty="0">
-                <a:solidFill>
-                  <a:srgbClr val="2E2055"/>
-                </a:solidFill>
-                <a:latin typeface="Calibri" pitchFamily="34" charset="0"/>
-                <a:ea typeface="Calibri" pitchFamily="34" charset="-122"/>
-                <a:cs typeface="Calibri" pitchFamily="34" charset="-120"/>
-              </a:rPr>
-              <a:t>Boat</a:t>
-            </a:r>
-            <a:endParaRPr lang="en-US" sz="2000" dirty="0"/>
-          </a:p>
-        </p:txBody>
-      </p:sp>
-      <p:sp>
-        <p:nvSpPr>
-          <p:cNvPr id="17" name="Text 15"/>
-          <p:cNvSpPr/>
-          <p:nvPr/>
-        </p:nvSpPr>
-        <p:spPr>
-          <a:xfrm>
-            <a:off x="6217920" y="4572000"/>
-            <a:ext cx="5486400" cy="365760"/>
+              <a:rPr lang="en-US" sz="1300" b="1" dirty="0">
+                <a:solidFill>
+                  <a:srgbClr val="E0457B"/>
+                </a:solidFill>
+                <a:latin typeface="Calibri" pitchFamily="34" charset="0"/>
+                <a:ea typeface="Calibri" pitchFamily="34" charset="-122"/>
+                <a:cs typeface="Calibri" pitchFamily="34" charset="-120"/>
+              </a:rPr>
+              <a:t>CR = ___</a:t>
+            </a:r>
+            <a:endParaRPr lang="en-US" sz="1300" dirty="0"/>
+          </a:p>
+          <a:p>
+            <a:pPr algn="ctr" indent="0" marL="0">
+              <a:buNone/>
+            </a:pPr>
+            <a:r>
+              <a:rPr lang="en-US" sz="1300" dirty="0">
+                <a:solidFill>
+                  <a:srgbClr val="1F1A33"/>
+                </a:solidFill>
+                <a:latin typeface="Calibri" pitchFamily="34" charset="0"/>
+                <a:ea typeface="Calibri" pitchFamily="34" charset="-122"/>
+                <a:cs typeface="Calibri" pitchFamily="34" charset="-120"/>
+              </a:rPr>
+              <a:t>PSNR 29.11 dB   SSIM 0.8394</a:t>
+            </a:r>
+            <a:endParaRPr lang="en-US" sz="1300" dirty="0"/>
+          </a:p>
+        </p:txBody>
+      </p:sp>
+      <p:sp>
+        <p:nvSpPr>
+          <p:cNvPr id="20" name="Text 18"/>
+          <p:cNvSpPr/>
+          <p:nvPr/>
+        </p:nvSpPr>
+        <p:spPr>
+          <a:xfrm>
+            <a:off x="6537960" y="1078992"/>
+            <a:ext cx="2331720" cy="301752"/>
           </a:xfrm>
           <a:prstGeom prst="rect">
             <a:avLst/>
@@ -2837,7 +2796,174 @@
               <a:buNone/>
             </a:pPr>
             <a:r>
-              <a:rPr lang="en-US" sz="1600" b="1" dirty="0">
+              <a:rPr lang="en-US" sz="1700" b="1" dirty="0">
+                <a:solidFill>
+                  <a:srgbClr val="2A9D8F"/>
+                </a:solidFill>
+                <a:latin typeface="Calibri" pitchFamily="34" charset="0"/>
+                <a:ea typeface="Calibri" pitchFamily="34" charset="-122"/>
+                <a:cs typeface="Calibri" pitchFamily="34" charset="-120"/>
+              </a:rPr>
+              <a:t>Cameraman</a:t>
+            </a:r>
+            <a:endParaRPr lang="en-US" sz="1700" dirty="0"/>
+          </a:p>
+        </p:txBody>
+      </p:sp>
+      <p:sp>
+        <p:nvSpPr>
+          <p:cNvPr id="21" name="Shape 19"/>
+          <p:cNvSpPr/>
+          <p:nvPr/>
+        </p:nvSpPr>
+        <p:spPr>
+          <a:xfrm>
+            <a:off x="6537960" y="1417320"/>
+            <a:ext cx="2331720" cy="2331720"/>
+          </a:xfrm>
+          <a:prstGeom prst="rect">
+            <a:avLst/>
+          </a:prstGeom>
+          <a:solidFill>
+            <a:srgbClr val="F5F1FB"/>
+          </a:solidFill>
+          <a:ln w="19050">
+            <a:solidFill>
+              <a:srgbClr val="6B4FA3"/>
+            </a:solidFill>
+            <a:prstDash val="dash"/>
+          </a:ln>
+        </p:spPr>
+      </p:sp>
+      <p:sp>
+        <p:nvSpPr>
+          <p:cNvPr id="22" name="Text 20"/>
+          <p:cNvSpPr/>
+          <p:nvPr/>
+        </p:nvSpPr>
+        <p:spPr>
+          <a:xfrm>
+            <a:off x="6537960" y="1417320"/>
+            <a:ext cx="2331720" cy="2331720"/>
+          </a:xfrm>
+          <a:prstGeom prst="rect">
+            <a:avLst/>
+          </a:prstGeom>
+          <a:noFill/>
+          <a:ln/>
+        </p:spPr>
+        <p:txBody>
+          <a:bodyPr wrap="square" lIns="1270" tIns="1270" rIns="1270" bIns="1270" rtlCol="0" anchor="ctr"/>
+          <a:lstStyle/>
+          <a:p>
+            <a:pPr algn="ctr" indent="0" marL="0">
+              <a:buNone/>
+            </a:pPr>
+            <a:r>
+              <a:rPr lang="en-US" sz="1400" i="1" dirty="0">
+                <a:solidFill>
+                  <a:srgbClr val="6B4FA3"/>
+                </a:solidFill>
+                <a:latin typeface="Calibri" pitchFamily="34" charset="0"/>
+                <a:ea typeface="Calibri" pitchFamily="34" charset="-122"/>
+                <a:cs typeface="Calibri" pitchFamily="34" charset="-120"/>
+              </a:rPr>
+              <a:t>Original</a:t>
+            </a:r>
+            <a:endParaRPr lang="en-US" sz="1400" dirty="0"/>
+          </a:p>
+        </p:txBody>
+      </p:sp>
+      <p:sp>
+        <p:nvSpPr>
+          <p:cNvPr id="23" name="Shape 21"/>
+          <p:cNvSpPr/>
+          <p:nvPr/>
+        </p:nvSpPr>
+        <p:spPr>
+          <a:xfrm>
+            <a:off x="6537960" y="3840480"/>
+            <a:ext cx="2331720" cy="2331720"/>
+          </a:xfrm>
+          <a:prstGeom prst="rect">
+            <a:avLst/>
+          </a:prstGeom>
+          <a:solidFill>
+            <a:srgbClr val="F5F1FB"/>
+          </a:solidFill>
+          <a:ln w="19050">
+            <a:solidFill>
+              <a:srgbClr val="6B4FA3"/>
+            </a:solidFill>
+            <a:prstDash val="dash"/>
+          </a:ln>
+        </p:spPr>
+      </p:sp>
+      <p:sp>
+        <p:nvSpPr>
+          <p:cNvPr id="24" name="Text 22"/>
+          <p:cNvSpPr/>
+          <p:nvPr/>
+        </p:nvSpPr>
+        <p:spPr>
+          <a:xfrm>
+            <a:off x="6537960" y="3840480"/>
+            <a:ext cx="2331720" cy="2331720"/>
+          </a:xfrm>
+          <a:prstGeom prst="rect">
+            <a:avLst/>
+          </a:prstGeom>
+          <a:noFill/>
+          <a:ln/>
+        </p:spPr>
+        <p:txBody>
+          <a:bodyPr wrap="square" lIns="1270" tIns="1270" rIns="1270" bIns="1270" rtlCol="0" anchor="ctr"/>
+          <a:lstStyle/>
+          <a:p>
+            <a:pPr algn="ctr" indent="0" marL="0">
+              <a:buNone/>
+            </a:pPr>
+            <a:r>
+              <a:rPr lang="en-US" sz="1400" i="1" dirty="0">
+                <a:solidFill>
+                  <a:srgbClr val="6B4FA3"/>
+                </a:solidFill>
+                <a:latin typeface="Calibri" pitchFamily="34" charset="0"/>
+                <a:ea typeface="Calibri" pitchFamily="34" charset="-122"/>
+                <a:cs typeface="Calibri" pitchFamily="34" charset="-120"/>
+              </a:rPr>
+              <a:t>Reconstructed</a:t>
+            </a:r>
+            <a:endParaRPr lang="en-US" sz="1400" dirty="0"/>
+          </a:p>
+        </p:txBody>
+      </p:sp>
+      <p:sp>
+        <p:nvSpPr>
+          <p:cNvPr id="25" name="Text 23"/>
+          <p:cNvSpPr/>
+          <p:nvPr/>
+        </p:nvSpPr>
+        <p:spPr>
+          <a:xfrm>
+            <a:off x="6446520" y="6199632"/>
+            <a:ext cx="2514600" cy="457200"/>
+          </a:xfrm>
+          <a:prstGeom prst="rect">
+            <a:avLst/>
+          </a:prstGeom>
+          <a:noFill/>
+          <a:ln/>
+        </p:spPr>
+        <p:txBody>
+          <a:bodyPr wrap="square" lIns="0" tIns="0" rIns="0" bIns="0" rtlCol="0" anchor="ctr"/>
+          <a:lstStyle/>
+          <a:p>
+            <a:pPr algn="ctr" indent="0" marL="0">
+              <a:buNone/>
+            </a:pPr>
+            <a:r>
+              <a:rPr lang="en-US" sz="1300" b="1" dirty="0">
                 <a:solidFill>
                   <a:srgbClr val="E0457B"/>
                 </a:solidFill>
@@ -2847,11 +2973,14 @@
               </a:rPr>
               <a:t>CR = ___</a:t>
             </a:r>
-            <a:pPr algn="ctr" indent="0" marL="0">
-              <a:buNone/>
-            </a:pPr>
-            <a:r>
-              <a:rPr lang="en-US" sz="1600" dirty="0">
+            <a:endParaRPr lang="en-US" sz="1300" dirty="0"/>
+          </a:p>
+          <a:p>
+            <a:pPr algn="ctr" indent="0" marL="0">
+              <a:buNone/>
+            </a:pPr>
+            <a:r>
+              <a:rPr lang="en-US" sz="1300" dirty="0">
                 <a:solidFill>
                   <a:srgbClr val="1F1A33"/>
                 </a:solidFill>
@@ -2859,22 +2988,22 @@
                 <a:ea typeface="Calibri" pitchFamily="34" charset="-122"/>
                 <a:cs typeface="Calibri" pitchFamily="34" charset="-120"/>
               </a:rPr>
-              <a:t>   |   PSNR = 29.11 dB   |   SSIM = 0.8394</a:t>
-            </a:r>
-            <a:endParaRPr lang="en-US" sz="1600" dirty="0"/>
-          </a:p>
-        </p:txBody>
-      </p:sp>
-      <p:sp>
-        <p:nvSpPr>
-          <p:cNvPr id="18" name="Text 16"/>
-          <p:cNvSpPr/>
-          <p:nvPr/>
-        </p:nvSpPr>
-        <p:spPr>
-          <a:xfrm>
-            <a:off x="457200" y="6172200"/>
-            <a:ext cx="11274552" cy="320040"/>
+              <a:t>PSNR 29.75 dB   SSIM 0.8855</a:t>
+            </a:r>
+            <a:endParaRPr lang="en-US" sz="1300" dirty="0"/>
+          </a:p>
+        </p:txBody>
+      </p:sp>
+      <p:sp>
+        <p:nvSpPr>
+          <p:cNvPr id="26" name="Text 24"/>
+          <p:cNvSpPr/>
+          <p:nvPr/>
+        </p:nvSpPr>
+        <p:spPr>
+          <a:xfrm>
+            <a:off x="9006840" y="1078992"/>
+            <a:ext cx="2331720" cy="301752"/>
           </a:xfrm>
           <a:prstGeom prst="rect">
             <a:avLst/>
@@ -2890,7 +3019,71 @@
               <a:buNone/>
             </a:pPr>
             <a:r>
-              <a:rPr lang="en-US" sz="1300" i="1" dirty="0">
+              <a:rPr lang="en-US" sz="1700" b="1" dirty="0">
+                <a:solidFill>
+                  <a:srgbClr val="2A9D8F"/>
+                </a:solidFill>
+                <a:latin typeface="Calibri" pitchFamily="34" charset="0"/>
+                <a:ea typeface="Calibri" pitchFamily="34" charset="-122"/>
+                <a:cs typeface="Calibri" pitchFamily="34" charset="-120"/>
+              </a:rPr>
+              <a:t>Peppers</a:t>
+            </a:r>
+            <a:endParaRPr lang="en-US" sz="1700" dirty="0"/>
+          </a:p>
+        </p:txBody>
+      </p:sp>
+      <p:sp>
+        <p:nvSpPr>
+          <p:cNvPr id="27" name="Shape 25"/>
+          <p:cNvSpPr/>
+          <p:nvPr/>
+        </p:nvSpPr>
+        <p:spPr>
+          <a:xfrm>
+            <a:off x="9006840" y="1417320"/>
+            <a:ext cx="2331720" cy="2331720"/>
+          </a:xfrm>
+          <a:prstGeom prst="rect">
+            <a:avLst/>
+          </a:prstGeom>
+          <a:solidFill>
+            <a:srgbClr val="F5F1FB"/>
+          </a:solidFill>
+          <a:ln w="19050">
+            <a:solidFill>
+              <a:srgbClr val="6B4FA3"/>
+            </a:solidFill>
+            <a:prstDash val="dash"/>
+          </a:ln>
+        </p:spPr>
+      </p:sp>
+      <p:sp>
+        <p:nvSpPr>
+          <p:cNvPr id="28" name="Text 26"/>
+          <p:cNvSpPr/>
+          <p:nvPr/>
+        </p:nvSpPr>
+        <p:spPr>
+          <a:xfrm>
+            <a:off x="9006840" y="1417320"/>
+            <a:ext cx="2331720" cy="2331720"/>
+          </a:xfrm>
+          <a:prstGeom prst="rect">
+            <a:avLst/>
+          </a:prstGeom>
+          <a:noFill/>
+          <a:ln/>
+        </p:spPr>
+        <p:txBody>
+          <a:bodyPr wrap="square" lIns="1270" tIns="1270" rIns="1270" bIns="1270" rtlCol="0" anchor="ctr"/>
+          <a:lstStyle/>
+          <a:p>
+            <a:pPr algn="ctr" indent="0" marL="0">
+              <a:buNone/>
+            </a:pPr>
+            <a:r>
+              <a:rPr lang="en-US" sz="1400" i="1" dirty="0">
                 <a:solidFill>
                   <a:srgbClr val="6B4FA3"/>
                 </a:solidFill>
@@ -2898,7 +3091,127 @@
                 <a:ea typeface="Calibri" pitchFamily="34" charset="-122"/>
                 <a:cs typeface="Calibri" pitchFamily="34" charset="-120"/>
               </a:rPr>
-              <a:t>Block size 4 × 4, K = 64. Same reconstruction for the sequential and parallel runs.</a:t>
+              <a:t>Original</a:t>
+            </a:r>
+            <a:endParaRPr lang="en-US" sz="1400" dirty="0"/>
+          </a:p>
+        </p:txBody>
+      </p:sp>
+      <p:sp>
+        <p:nvSpPr>
+          <p:cNvPr id="29" name="Shape 27"/>
+          <p:cNvSpPr/>
+          <p:nvPr/>
+        </p:nvSpPr>
+        <p:spPr>
+          <a:xfrm>
+            <a:off x="9006840" y="3840480"/>
+            <a:ext cx="2331720" cy="2331720"/>
+          </a:xfrm>
+          <a:prstGeom prst="rect">
+            <a:avLst/>
+          </a:prstGeom>
+          <a:solidFill>
+            <a:srgbClr val="F5F1FB"/>
+          </a:solidFill>
+          <a:ln w="19050">
+            <a:solidFill>
+              <a:srgbClr val="6B4FA3"/>
+            </a:solidFill>
+            <a:prstDash val="dash"/>
+          </a:ln>
+        </p:spPr>
+      </p:sp>
+      <p:sp>
+        <p:nvSpPr>
+          <p:cNvPr id="30" name="Text 28"/>
+          <p:cNvSpPr/>
+          <p:nvPr/>
+        </p:nvSpPr>
+        <p:spPr>
+          <a:xfrm>
+            <a:off x="9006840" y="3840480"/>
+            <a:ext cx="2331720" cy="2331720"/>
+          </a:xfrm>
+          <a:prstGeom prst="rect">
+            <a:avLst/>
+          </a:prstGeom>
+          <a:noFill/>
+          <a:ln/>
+        </p:spPr>
+        <p:txBody>
+          <a:bodyPr wrap="square" lIns="1270" tIns="1270" rIns="1270" bIns="1270" rtlCol="0" anchor="ctr"/>
+          <a:lstStyle/>
+          <a:p>
+            <a:pPr algn="ctr" indent="0" marL="0">
+              <a:buNone/>
+            </a:pPr>
+            <a:r>
+              <a:rPr lang="en-US" sz="1400" i="1" dirty="0">
+                <a:solidFill>
+                  <a:srgbClr val="6B4FA3"/>
+                </a:solidFill>
+                <a:latin typeface="Calibri" pitchFamily="34" charset="0"/>
+                <a:ea typeface="Calibri" pitchFamily="34" charset="-122"/>
+                <a:cs typeface="Calibri" pitchFamily="34" charset="-120"/>
+              </a:rPr>
+              <a:t>Reconstructed</a:t>
+            </a:r>
+            <a:endParaRPr lang="en-US" sz="1400" dirty="0"/>
+          </a:p>
+        </p:txBody>
+      </p:sp>
+      <p:sp>
+        <p:nvSpPr>
+          <p:cNvPr id="31" name="Text 29"/>
+          <p:cNvSpPr/>
+          <p:nvPr/>
+        </p:nvSpPr>
+        <p:spPr>
+          <a:xfrm>
+            <a:off x="8915400" y="6199632"/>
+            <a:ext cx="2514600" cy="457200"/>
+          </a:xfrm>
+          <a:prstGeom prst="rect">
+            <a:avLst/>
+          </a:prstGeom>
+          <a:noFill/>
+          <a:ln/>
+        </p:spPr>
+        <p:txBody>
+          <a:bodyPr wrap="square" lIns="0" tIns="0" rIns="0" bIns="0" rtlCol="0" anchor="ctr"/>
+          <a:lstStyle/>
+          <a:p>
+            <a:pPr algn="ctr" indent="0" marL="0">
+              <a:buNone/>
+            </a:pPr>
+            <a:r>
+              <a:rPr lang="en-US" sz="1300" b="1" dirty="0">
+                <a:solidFill>
+                  <a:srgbClr val="E0457B"/>
+                </a:solidFill>
+                <a:latin typeface="Calibri" pitchFamily="34" charset="0"/>
+                <a:ea typeface="Calibri" pitchFamily="34" charset="-122"/>
+                <a:cs typeface="Calibri" pitchFamily="34" charset="-120"/>
+              </a:rPr>
+              <a:t>CR = ___</a:t>
+            </a:r>
+            <a:endParaRPr lang="en-US" sz="1300" dirty="0"/>
+          </a:p>
+          <a:p>
+            <a:pPr algn="ctr" indent="0" marL="0">
+              <a:buNone/>
+            </a:pPr>
+            <a:r>
+              <a:rPr lang="en-US" sz="1300" dirty="0">
+                <a:solidFill>
+                  <a:srgbClr val="1F1A33"/>
+                </a:solidFill>
+                <a:latin typeface="Calibri" pitchFamily="34" charset="0"/>
+                <a:ea typeface="Calibri" pitchFamily="34" charset="-122"/>
+                <a:cs typeface="Calibri" pitchFamily="34" charset="-120"/>
+              </a:rPr>
+              <a:t>PSNR 29.41 dB   SSIM 0.7624</a:t>
             </a:r>
             <a:endParaRPr lang="en-US" sz="1300" dirty="0"/>
           </a:p>
@@ -3035,7 +3348,7 @@
                 <a:ea typeface="Cambria" pitchFamily="34" charset="-122"/>
                 <a:cs typeface="Cambria" pitchFamily="34" charset="-120"/>
               </a:rPr>
-              <a:t>Original vs Reconstructed: Grayscale</a:t>
+              <a:t>Reconstruction Results: Color Images</a:t>
             </a:r>
             <a:endParaRPr lang="en-US" sz="2800" dirty="0"/>
           </a:p>
@@ -3068,14 +3381,131 @@
       </p:sp>
       <p:sp>
         <p:nvSpPr>
-          <p:cNvPr id="6" name="Shape 4"/>
-          <p:cNvSpPr/>
-          <p:nvPr/>
-        </p:nvSpPr>
-        <p:spPr>
-          <a:xfrm>
-            <a:off x="457200" y="1371600"/>
-            <a:ext cx="2697480" cy="2697480"/>
+          <p:cNvPr id="6" name="Text 4"/>
+          <p:cNvSpPr/>
+          <p:nvPr/>
+        </p:nvSpPr>
+        <p:spPr>
+          <a:xfrm>
+            <a:off x="411480" y="1417320"/>
+            <a:ext cx="1097280" cy="2331720"/>
+          </a:xfrm>
+          <a:prstGeom prst="rect">
+            <a:avLst/>
+          </a:prstGeom>
+          <a:noFill/>
+          <a:ln/>
+        </p:spPr>
+        <p:txBody>
+          <a:bodyPr wrap="square" lIns="0" tIns="0" rIns="0" bIns="0" rtlCol="0" anchor="ctr"/>
+          <a:lstStyle/>
+          <a:p>
+            <a:pPr algn="ctr" indent="0" marL="0">
+              <a:buNone/>
+            </a:pPr>
+            <a:r>
+              <a:rPr lang="en-US" sz="1500" b="1" dirty="0">
+                <a:solidFill>
+                  <a:srgbClr val="2E2055"/>
+                </a:solidFill>
+                <a:latin typeface="Calibri" pitchFamily="34" charset="0"/>
+                <a:ea typeface="Calibri" pitchFamily="34" charset="-122"/>
+                <a:cs typeface="Calibri" pitchFamily="34" charset="-120"/>
+              </a:rPr>
+              <a:t>Original</a:t>
+            </a:r>
+            <a:endParaRPr lang="en-US" sz="1500" dirty="0"/>
+          </a:p>
+        </p:txBody>
+      </p:sp>
+      <p:sp>
+        <p:nvSpPr>
+          <p:cNvPr id="7" name="Text 5"/>
+          <p:cNvSpPr/>
+          <p:nvPr/>
+        </p:nvSpPr>
+        <p:spPr>
+          <a:xfrm>
+            <a:off x="411480" y="3840480"/>
+            <a:ext cx="1097280" cy="2331720"/>
+          </a:xfrm>
+          <a:prstGeom prst="rect">
+            <a:avLst/>
+          </a:prstGeom>
+          <a:noFill/>
+          <a:ln/>
+        </p:spPr>
+        <p:txBody>
+          <a:bodyPr wrap="square" lIns="0" tIns="0" rIns="0" bIns="0" rtlCol="0" anchor="ctr"/>
+          <a:lstStyle/>
+          <a:p>
+            <a:pPr algn="ctr" indent="0" marL="0">
+              <a:buNone/>
+            </a:pPr>
+            <a:r>
+              <a:rPr lang="en-US" sz="1500" b="1" dirty="0">
+                <a:solidFill>
+                  <a:srgbClr val="2E2055"/>
+                </a:solidFill>
+                <a:latin typeface="Calibri" pitchFamily="34" charset="0"/>
+                <a:ea typeface="Calibri" pitchFamily="34" charset="-122"/>
+                <a:cs typeface="Calibri" pitchFamily="34" charset="-120"/>
+              </a:rPr>
+              <a:t>Reconstructed</a:t>
+            </a:r>
+            <a:endParaRPr lang="en-US" sz="1500" dirty="0"/>
+          </a:p>
+        </p:txBody>
+      </p:sp>
+      <p:sp>
+        <p:nvSpPr>
+          <p:cNvPr id="8" name="Text 6"/>
+          <p:cNvSpPr/>
+          <p:nvPr/>
+        </p:nvSpPr>
+        <p:spPr>
+          <a:xfrm>
+            <a:off x="1600200" y="1078992"/>
+            <a:ext cx="2331720" cy="301752"/>
+          </a:xfrm>
+          <a:prstGeom prst="rect">
+            <a:avLst/>
+          </a:prstGeom>
+          <a:noFill/>
+          <a:ln/>
+        </p:spPr>
+        <p:txBody>
+          <a:bodyPr wrap="square" lIns="0" tIns="0" rIns="0" bIns="0" rtlCol="0" anchor="ctr"/>
+          <a:lstStyle/>
+          <a:p>
+            <a:pPr algn="ctr" indent="0" marL="0">
+              <a:buNone/>
+            </a:pPr>
+            <a:r>
+              <a:rPr lang="en-US" sz="1700" b="1" dirty="0">
+                <a:solidFill>
+                  <a:srgbClr val="2A9D8F"/>
+                </a:solidFill>
+                <a:latin typeface="Calibri" pitchFamily="34" charset="0"/>
+                <a:ea typeface="Calibri" pitchFamily="34" charset="-122"/>
+                <a:cs typeface="Calibri" pitchFamily="34" charset="-120"/>
+              </a:rPr>
+              <a:t>Lena</a:t>
+            </a:r>
+            <a:endParaRPr lang="en-US" sz="1700" dirty="0"/>
+          </a:p>
+        </p:txBody>
+      </p:sp>
+      <p:sp>
+        <p:nvSpPr>
+          <p:cNvPr id="9" name="Shape 7"/>
+          <p:cNvSpPr/>
+          <p:nvPr/>
+        </p:nvSpPr>
+        <p:spPr>
+          <a:xfrm>
+            <a:off x="1600200" y="1417320"/>
+            <a:ext cx="2331720" cy="2331720"/>
           </a:xfrm>
           <a:prstGeom prst="rect">
             <a:avLst/>
@@ -3093,14 +3523,14 @@
       </p:sp>
       <p:sp>
         <p:nvSpPr>
-          <p:cNvPr id="7" name="Text 5"/>
-          <p:cNvSpPr/>
-          <p:nvPr/>
-        </p:nvSpPr>
-        <p:spPr>
-          <a:xfrm>
-            <a:off x="457200" y="1371600"/>
-            <a:ext cx="2697480" cy="2697480"/>
+          <p:cNvPr id="10" name="Text 8"/>
+          <p:cNvSpPr/>
+          <p:nvPr/>
+        </p:nvSpPr>
+        <p:spPr>
+          <a:xfrm>
+            <a:off x="1600200" y="1417320"/>
+            <a:ext cx="2331720" cy="2331720"/>
           </a:xfrm>
           <a:prstGeom prst="rect">
             <a:avLst/>
@@ -3132,14 +3562,14 @@
       </p:sp>
       <p:sp>
         <p:nvSpPr>
-          <p:cNvPr id="8" name="Shape 6"/>
-          <p:cNvSpPr/>
-          <p:nvPr/>
-        </p:nvSpPr>
-        <p:spPr>
-          <a:xfrm>
-            <a:off x="3246120" y="1371600"/>
-            <a:ext cx="2697480" cy="2697480"/>
+          <p:cNvPr id="11" name="Shape 9"/>
+          <p:cNvSpPr/>
+          <p:nvPr/>
+        </p:nvSpPr>
+        <p:spPr>
+          <a:xfrm>
+            <a:off x="1600200" y="3840480"/>
+            <a:ext cx="2331720" cy="2331720"/>
           </a:xfrm>
           <a:prstGeom prst="rect">
             <a:avLst/>
@@ -3157,14 +3587,14 @@
       </p:sp>
       <p:sp>
         <p:nvSpPr>
-          <p:cNvPr id="9" name="Text 7"/>
-          <p:cNvSpPr/>
-          <p:nvPr/>
-        </p:nvSpPr>
-        <p:spPr>
-          <a:xfrm>
-            <a:off x="3246120" y="1371600"/>
-            <a:ext cx="2697480" cy="2697480"/>
+          <p:cNvPr id="12" name="Text 10"/>
+          <p:cNvSpPr/>
+          <p:nvPr/>
+        </p:nvSpPr>
+        <p:spPr>
+          <a:xfrm>
+            <a:off x="1600200" y="3840480"/>
+            <a:ext cx="2331720" cy="2331720"/>
           </a:xfrm>
           <a:prstGeom prst="rect">
             <a:avLst/>
@@ -3196,14 +3626,14 @@
       </p:sp>
       <p:sp>
         <p:nvSpPr>
-          <p:cNvPr id="10" name="Text 8"/>
-          <p:cNvSpPr/>
-          <p:nvPr/>
-        </p:nvSpPr>
-        <p:spPr>
-          <a:xfrm>
-            <a:off x="457200" y="4178808"/>
-            <a:ext cx="5486400" cy="365760"/>
+          <p:cNvPr id="13" name="Text 11"/>
+          <p:cNvSpPr/>
+          <p:nvPr/>
+        </p:nvSpPr>
+        <p:spPr>
+          <a:xfrm>
+            <a:off x="1508760" y="6199632"/>
+            <a:ext cx="2514600" cy="457200"/>
           </a:xfrm>
           <a:prstGeom prst="rect">
             <a:avLst/>
@@ -3219,30 +3649,47 @@
               <a:buNone/>
             </a:pPr>
             <a:r>
-              <a:rPr lang="en-US" sz="2000" b="1" dirty="0">
-                <a:solidFill>
-                  <a:srgbClr val="2E2055"/>
-                </a:solidFill>
-                <a:latin typeface="Calibri" pitchFamily="34" charset="0"/>
-                <a:ea typeface="Calibri" pitchFamily="34" charset="-122"/>
-                <a:cs typeface="Calibri" pitchFamily="34" charset="-120"/>
-              </a:rPr>
-              <a:t>Cameraman</a:t>
-            </a:r>
-            <a:endParaRPr lang="en-US" sz="2000" dirty="0"/>
-          </a:p>
-        </p:txBody>
-      </p:sp>
-      <p:sp>
-        <p:nvSpPr>
-          <p:cNvPr id="11" name="Text 9"/>
-          <p:cNvSpPr/>
-          <p:nvPr/>
-        </p:nvSpPr>
-        <p:spPr>
-          <a:xfrm>
-            <a:off x="457200" y="4572000"/>
-            <a:ext cx="5486400" cy="365760"/>
+              <a:rPr lang="en-US" sz="1300" b="1" dirty="0">
+                <a:solidFill>
+                  <a:srgbClr val="E0457B"/>
+                </a:solidFill>
+                <a:latin typeface="Calibri" pitchFamily="34" charset="0"/>
+                <a:ea typeface="Calibri" pitchFamily="34" charset="-122"/>
+                <a:cs typeface="Calibri" pitchFamily="34" charset="-120"/>
+              </a:rPr>
+              <a:t>CR = ___</a:t>
+            </a:r>
+            <a:endParaRPr lang="en-US" sz="1300" dirty="0"/>
+          </a:p>
+          <a:p>
+            <a:pPr algn="ctr" indent="0" marL="0">
+              <a:buNone/>
+            </a:pPr>
+            <a:r>
+              <a:rPr lang="en-US" sz="1300" dirty="0">
+                <a:solidFill>
+                  <a:srgbClr val="1F1A33"/>
+                </a:solidFill>
+                <a:latin typeface="Calibri" pitchFamily="34" charset="0"/>
+                <a:ea typeface="Calibri" pitchFamily="34" charset="-122"/>
+                <a:cs typeface="Calibri" pitchFamily="34" charset="-120"/>
+              </a:rPr>
+              <a:t>PSNR 28.91 dB   SSIM 0.7594</a:t>
+            </a:r>
+            <a:endParaRPr lang="en-US" sz="1300" dirty="0"/>
+          </a:p>
+        </p:txBody>
+      </p:sp>
+      <p:sp>
+        <p:nvSpPr>
+          <p:cNvPr id="14" name="Text 12"/>
+          <p:cNvSpPr/>
+          <p:nvPr/>
+        </p:nvSpPr>
+        <p:spPr>
+          <a:xfrm>
+            <a:off x="4069080" y="1078992"/>
+            <a:ext cx="2331720" cy="301752"/>
           </a:xfrm>
           <a:prstGeom prst="rect">
             <a:avLst/>
@@ -3258,44 +3705,30 @@
               <a:buNone/>
             </a:pPr>
             <a:r>
-              <a:rPr lang="en-US" sz="1600" b="1" dirty="0">
-                <a:solidFill>
-                  <a:srgbClr val="E0457B"/>
-                </a:solidFill>
-                <a:latin typeface="Calibri" pitchFamily="34" charset="0"/>
-                <a:ea typeface="Calibri" pitchFamily="34" charset="-122"/>
-                <a:cs typeface="Calibri" pitchFamily="34" charset="-120"/>
-              </a:rPr>
-              <a:t>CR = ___</a:t>
-            </a:r>
-            <a:pPr algn="ctr" indent="0" marL="0">
-              <a:buNone/>
-            </a:pPr>
-            <a:r>
-              <a:rPr lang="en-US" sz="1600" dirty="0">
-                <a:solidFill>
-                  <a:srgbClr val="1F1A33"/>
-                </a:solidFill>
-                <a:latin typeface="Calibri" pitchFamily="34" charset="0"/>
-                <a:ea typeface="Calibri" pitchFamily="34" charset="-122"/>
-                <a:cs typeface="Calibri" pitchFamily="34" charset="-120"/>
-              </a:rPr>
-              <a:t>   |   PSNR = 29.75 dB   |   SSIM = 0.8855</a:t>
-            </a:r>
-            <a:endParaRPr lang="en-US" sz="1600" dirty="0"/>
-          </a:p>
-        </p:txBody>
-      </p:sp>
-      <p:sp>
-        <p:nvSpPr>
-          <p:cNvPr id="12" name="Shape 10"/>
-          <p:cNvSpPr/>
-          <p:nvPr/>
-        </p:nvSpPr>
-        <p:spPr>
-          <a:xfrm>
-            <a:off x="6217920" y="1371600"/>
-            <a:ext cx="2697480" cy="2697480"/>
+              <a:rPr lang="en-US" sz="1700" b="1" dirty="0">
+                <a:solidFill>
+                  <a:srgbClr val="2A9D8F"/>
+                </a:solidFill>
+                <a:latin typeface="Calibri" pitchFamily="34" charset="0"/>
+                <a:ea typeface="Calibri" pitchFamily="34" charset="-122"/>
+                <a:cs typeface="Calibri" pitchFamily="34" charset="-120"/>
+              </a:rPr>
+              <a:t>Peppers</a:t>
+            </a:r>
+            <a:endParaRPr lang="en-US" sz="1700" dirty="0"/>
+          </a:p>
+        </p:txBody>
+      </p:sp>
+      <p:sp>
+        <p:nvSpPr>
+          <p:cNvPr id="15" name="Shape 13"/>
+          <p:cNvSpPr/>
+          <p:nvPr/>
+        </p:nvSpPr>
+        <p:spPr>
+          <a:xfrm>
+            <a:off x="4069080" y="1417320"/>
+            <a:ext cx="2331720" cy="2331720"/>
           </a:xfrm>
           <a:prstGeom prst="rect">
             <a:avLst/>
@@ -3313,14 +3746,14 @@
       </p:sp>
       <p:sp>
         <p:nvSpPr>
-          <p:cNvPr id="13" name="Text 11"/>
-          <p:cNvSpPr/>
-          <p:nvPr/>
-        </p:nvSpPr>
-        <p:spPr>
-          <a:xfrm>
-            <a:off x="6217920" y="1371600"/>
-            <a:ext cx="2697480" cy="2697480"/>
+          <p:cNvPr id="16" name="Text 14"/>
+          <p:cNvSpPr/>
+          <p:nvPr/>
+        </p:nvSpPr>
+        <p:spPr>
+          <a:xfrm>
+            <a:off x="4069080" y="1417320"/>
+            <a:ext cx="2331720" cy="2331720"/>
           </a:xfrm>
           <a:prstGeom prst="rect">
             <a:avLst/>
@@ -3352,14 +3785,14 @@
       </p:sp>
       <p:sp>
         <p:nvSpPr>
-          <p:cNvPr id="14" name="Shape 12"/>
-          <p:cNvSpPr/>
-          <p:nvPr/>
-        </p:nvSpPr>
-        <p:spPr>
-          <a:xfrm>
-            <a:off x="9006840" y="1371600"/>
-            <a:ext cx="2697480" cy="2697480"/>
+          <p:cNvPr id="17" name="Shape 15"/>
+          <p:cNvSpPr/>
+          <p:nvPr/>
+        </p:nvSpPr>
+        <p:spPr>
+          <a:xfrm>
+            <a:off x="4069080" y="3840480"/>
+            <a:ext cx="2331720" cy="2331720"/>
           </a:xfrm>
           <a:prstGeom prst="rect">
             <a:avLst/>
@@ -3377,14 +3810,14 @@
       </p:sp>
       <p:sp>
         <p:nvSpPr>
-          <p:cNvPr id="15" name="Text 13"/>
-          <p:cNvSpPr/>
-          <p:nvPr/>
-        </p:nvSpPr>
-        <p:spPr>
-          <a:xfrm>
-            <a:off x="9006840" y="1371600"/>
-            <a:ext cx="2697480" cy="2697480"/>
+          <p:cNvPr id="18" name="Text 16"/>
+          <p:cNvSpPr/>
+          <p:nvPr/>
+        </p:nvSpPr>
+        <p:spPr>
+          <a:xfrm>
+            <a:off x="4069080" y="3840480"/>
+            <a:ext cx="2331720" cy="2331720"/>
           </a:xfrm>
           <a:prstGeom prst="rect">
             <a:avLst/>
@@ -3416,14 +3849,14 @@
       </p:sp>
       <p:sp>
         <p:nvSpPr>
-          <p:cNvPr id="16" name="Text 14"/>
-          <p:cNvSpPr/>
-          <p:nvPr/>
-        </p:nvSpPr>
-        <p:spPr>
-          <a:xfrm>
-            <a:off x="6217920" y="4178808"/>
-            <a:ext cx="5486400" cy="365760"/>
+          <p:cNvPr id="19" name="Text 17"/>
+          <p:cNvSpPr/>
+          <p:nvPr/>
+        </p:nvSpPr>
+        <p:spPr>
+          <a:xfrm>
+            <a:off x="3977640" y="6199632"/>
+            <a:ext cx="2514600" cy="457200"/>
           </a:xfrm>
           <a:prstGeom prst="rect">
             <a:avLst/>
@@ -3439,30 +3872,47 @@
               <a:buNone/>
             </a:pPr>
             <a:r>
-              <a:rPr lang="en-US" sz="2000" b="1" dirty="0">
-                <a:solidFill>
-                  <a:srgbClr val="2E2055"/>
-                </a:solidFill>
-                <a:latin typeface="Calibri" pitchFamily="34" charset="0"/>
-                <a:ea typeface="Calibri" pitchFamily="34" charset="-122"/>
-                <a:cs typeface="Calibri" pitchFamily="34" charset="-120"/>
-              </a:rPr>
-              <a:t>Peppers</a:t>
-            </a:r>
-            <a:endParaRPr lang="en-US" sz="2000" dirty="0"/>
-          </a:p>
-        </p:txBody>
-      </p:sp>
-      <p:sp>
-        <p:nvSpPr>
-          <p:cNvPr id="17" name="Text 15"/>
-          <p:cNvSpPr/>
-          <p:nvPr/>
-        </p:nvSpPr>
-        <p:spPr>
-          <a:xfrm>
-            <a:off x="6217920" y="4572000"/>
-            <a:ext cx="5486400" cy="365760"/>
+              <a:rPr lang="en-US" sz="1300" b="1" dirty="0">
+                <a:solidFill>
+                  <a:srgbClr val="E0457B"/>
+                </a:solidFill>
+                <a:latin typeface="Calibri" pitchFamily="34" charset="0"/>
+                <a:ea typeface="Calibri" pitchFamily="34" charset="-122"/>
+                <a:cs typeface="Calibri" pitchFamily="34" charset="-120"/>
+              </a:rPr>
+              <a:t>CR = ___</a:t>
+            </a:r>
+            <a:endParaRPr lang="en-US" sz="1300" dirty="0"/>
+          </a:p>
+          <a:p>
+            <a:pPr algn="ctr" indent="0" marL="0">
+              <a:buNone/>
+            </a:pPr>
+            <a:r>
+              <a:rPr lang="en-US" sz="1300" dirty="0">
+                <a:solidFill>
+                  <a:srgbClr val="1F1A33"/>
+                </a:solidFill>
+                <a:latin typeface="Calibri" pitchFamily="34" charset="0"/>
+                <a:ea typeface="Calibri" pitchFamily="34" charset="-122"/>
+                <a:cs typeface="Calibri" pitchFamily="34" charset="-120"/>
+              </a:rPr>
+              <a:t>PSNR 28.35 dB   SSIM 0.6964</a:t>
+            </a:r>
+            <a:endParaRPr lang="en-US" sz="1300" dirty="0"/>
+          </a:p>
+        </p:txBody>
+      </p:sp>
+      <p:sp>
+        <p:nvSpPr>
+          <p:cNvPr id="20" name="Text 18"/>
+          <p:cNvSpPr/>
+          <p:nvPr/>
+        </p:nvSpPr>
+        <p:spPr>
+          <a:xfrm>
+            <a:off x="6537960" y="1078992"/>
+            <a:ext cx="2331720" cy="301752"/>
           </a:xfrm>
           <a:prstGeom prst="rect">
             <a:avLst/>
@@ -3478,245 +3928,30 @@
               <a:buNone/>
             </a:pPr>
             <a:r>
-              <a:rPr lang="en-US" sz="1600" b="1" dirty="0">
-                <a:solidFill>
-                  <a:srgbClr val="E0457B"/>
-                </a:solidFill>
-                <a:latin typeface="Calibri" pitchFamily="34" charset="0"/>
-                <a:ea typeface="Calibri" pitchFamily="34" charset="-122"/>
-                <a:cs typeface="Calibri" pitchFamily="34" charset="-120"/>
-              </a:rPr>
-              <a:t>CR = ___</a:t>
-            </a:r>
-            <a:pPr algn="ctr" indent="0" marL="0">
-              <a:buNone/>
-            </a:pPr>
-            <a:r>
-              <a:rPr lang="en-US" sz="1600" dirty="0">
-                <a:solidFill>
-                  <a:srgbClr val="1F1A33"/>
-                </a:solidFill>
-                <a:latin typeface="Calibri" pitchFamily="34" charset="0"/>
-                <a:ea typeface="Calibri" pitchFamily="34" charset="-122"/>
-                <a:cs typeface="Calibri" pitchFamily="34" charset="-120"/>
-              </a:rPr>
-              <a:t>   |   PSNR = 29.41 dB   |   SSIM = 0.7624</a:t>
-            </a:r>
-            <a:endParaRPr lang="en-US" sz="1600" dirty="0"/>
-          </a:p>
-        </p:txBody>
-      </p:sp>
-      <p:sp>
-        <p:nvSpPr>
-          <p:cNvPr id="18" name="Text 16"/>
-          <p:cNvSpPr/>
-          <p:nvPr/>
-        </p:nvSpPr>
-        <p:spPr>
-          <a:xfrm>
-            <a:off x="457200" y="6172200"/>
-            <a:ext cx="11274552" cy="320040"/>
-          </a:xfrm>
-          <a:prstGeom prst="rect">
-            <a:avLst/>
-          </a:prstGeom>
-          <a:noFill/>
-          <a:ln/>
-        </p:spPr>
-        <p:txBody>
-          <a:bodyPr wrap="square" lIns="0" tIns="0" rIns="0" bIns="0" rtlCol="0" anchor="ctr"/>
-          <a:lstStyle/>
-          <a:p>
-            <a:pPr algn="ctr" indent="0" marL="0">
-              <a:buNone/>
-            </a:pPr>
-            <a:r>
-              <a:rPr lang="en-US" sz="1300" i="1" dirty="0">
-                <a:solidFill>
-                  <a:srgbClr val="6B4FA3"/>
-                </a:solidFill>
-                <a:latin typeface="Calibri" pitchFamily="34" charset="0"/>
-                <a:ea typeface="Calibri" pitchFamily="34" charset="-122"/>
-                <a:cs typeface="Calibri" pitchFamily="34" charset="-120"/>
-              </a:rPr>
-              <a:t>Block size 4 × 4, K = 64. Same reconstruction for the sequential and parallel runs.</a:t>
-            </a:r>
-            <a:endParaRPr lang="en-US" sz="1300" dirty="0"/>
-          </a:p>
-        </p:txBody>
-      </p:sp>
-    </p:spTree>
-  </p:cSld>
-  <p:clrMapOvr>
-    <a:masterClrMapping/>
-  </p:clrMapOvr>
-</p:sld>
-</file>
-
-<file path=ppt/slides/slide4.xml><?xml version="1.0" encoding="utf-8"?>
-<p:sld xmlns:a="http://schemas.openxmlformats.org/drawingml/2006/main" xmlns:r="http://schemas.openxmlformats.org/officeDocument/2006/relationships" xmlns:p="http://schemas.openxmlformats.org/presentationml/2006/main">
-  <p:cSld name="Slide 4">
-    <p:bg>
-      <p:bgPr>
-        <a:solidFill>
-          <a:srgbClr val="FFFFFF"/>
-        </a:solidFill>
-      </p:bgPr>
-    </p:bg>
-    <p:spTree>
-      <p:nvGrpSpPr>
-        <p:cNvPr id="1" name=""/>
-        <p:cNvGrpSpPr/>
-        <p:nvPr/>
-      </p:nvGrpSpPr>
-      <p:grpSpPr>
-        <a:xfrm>
-          <a:off x="0" y="0"/>
-          <a:ext cx="0" cy="0"/>
-          <a:chOff x="0" y="0"/>
-          <a:chExt cx="0" cy="0"/>
-        </a:xfrm>
-      </p:grpSpPr>
-      <p:sp>
-        <p:nvSpPr>
-          <p:cNvPr id="2" name="Shape 0"/>
-          <p:cNvSpPr/>
-          <p:nvPr/>
-        </p:nvSpPr>
-        <p:spPr>
-          <a:xfrm>
-            <a:off x="457200" y="320040"/>
-            <a:ext cx="1737360" cy="502920"/>
-          </a:xfrm>
-          <a:prstGeom prst="roundRect">
-            <a:avLst>
-              <a:gd name="adj" fmla="val 18182"/>
-            </a:avLst>
-          </a:prstGeom>
-          <a:solidFill>
-            <a:srgbClr val="2A9D8F"/>
-          </a:solidFill>
-          <a:ln w="12700">
-            <a:solidFill>
-              <a:srgbClr val="2A9D8F"/>
-            </a:solidFill>
-            <a:prstDash val="solid"/>
-          </a:ln>
-        </p:spPr>
-      </p:sp>
-      <p:sp>
-        <p:nvSpPr>
-          <p:cNvPr id="3" name="Text 1"/>
-          <p:cNvSpPr/>
-          <p:nvPr/>
-        </p:nvSpPr>
-        <p:spPr>
-          <a:xfrm>
-            <a:off x="457200" y="320040"/>
-            <a:ext cx="1737360" cy="502920"/>
-          </a:xfrm>
-          <a:prstGeom prst="rect">
-            <a:avLst/>
-          </a:prstGeom>
-          <a:noFill/>
-          <a:ln/>
-        </p:spPr>
-        <p:txBody>
-          <a:bodyPr wrap="square" lIns="0" tIns="0" rIns="0" bIns="0" rtlCol="0" anchor="ctr"/>
-          <a:lstStyle/>
-          <a:p>
-            <a:pPr algn="ctr" indent="0" marL="0">
-              <a:buNone/>
-            </a:pPr>
-            <a:r>
-              <a:rPr lang="en-US" sz="1800" b="1" dirty="0">
-                <a:solidFill>
-                  <a:srgbClr val="FFFFFF"/>
-                </a:solidFill>
-                <a:latin typeface="Calibri" pitchFamily="34" charset="0"/>
-                <a:ea typeface="Calibri" pitchFamily="34" charset="-122"/>
-                <a:cs typeface="Calibri" pitchFamily="34" charset="-120"/>
-              </a:rPr>
-              <a:t>Results</a:t>
-            </a:r>
-            <a:endParaRPr lang="en-US" sz="1800" dirty="0"/>
-          </a:p>
-        </p:txBody>
-      </p:sp>
-      <p:sp>
-        <p:nvSpPr>
-          <p:cNvPr id="4" name="Text 2"/>
-          <p:cNvSpPr/>
-          <p:nvPr/>
-        </p:nvSpPr>
-        <p:spPr>
-          <a:xfrm>
-            <a:off x="2377440" y="274320"/>
-            <a:ext cx="9326880" cy="594360"/>
-          </a:xfrm>
-          <a:prstGeom prst="rect">
-            <a:avLst/>
-          </a:prstGeom>
-          <a:noFill/>
-          <a:ln/>
-        </p:spPr>
-        <p:txBody>
-          <a:bodyPr wrap="square" lIns="0" tIns="0" rIns="0" bIns="0" rtlCol="0" anchor="ctr"/>
-          <a:lstStyle/>
-          <a:p>
-            <a:pPr indent="0" marL="0">
-              <a:buNone/>
-            </a:pPr>
-            <a:r>
-              <a:rPr lang="en-US" sz="2800" b="1" dirty="0">
-                <a:solidFill>
-                  <a:srgbClr val="2E2055"/>
-                </a:solidFill>
-                <a:latin typeface="Cambria" pitchFamily="34" charset="0"/>
-                <a:ea typeface="Cambria" pitchFamily="34" charset="-122"/>
-                <a:cs typeface="Cambria" pitchFamily="34" charset="-120"/>
-              </a:rPr>
-              <a:t>Original vs Reconstructed: Color</a:t>
-            </a:r>
-            <a:endParaRPr lang="en-US" sz="2800" dirty="0"/>
-          </a:p>
-        </p:txBody>
-      </p:sp>
-      <p:sp>
-        <p:nvSpPr>
-          <p:cNvPr id="5" name="Shape 3"/>
-          <p:cNvSpPr/>
-          <p:nvPr/>
-        </p:nvSpPr>
-        <p:spPr>
-          <a:xfrm>
-            <a:off x="457200" y="960120"/>
-            <a:ext cx="11274552" cy="36576"/>
-          </a:xfrm>
-          <a:prstGeom prst="rect">
-            <a:avLst/>
-          </a:prstGeom>
-          <a:solidFill>
-            <a:srgbClr val="2A9D8F"/>
-          </a:solidFill>
-          <a:ln w="12700">
-            <a:solidFill>
-              <a:srgbClr val="2A9D8F"/>
-            </a:solidFill>
-            <a:prstDash val="solid"/>
-          </a:ln>
-        </p:spPr>
-      </p:sp>
-      <p:sp>
-        <p:nvSpPr>
-          <p:cNvPr id="6" name="Shape 4"/>
-          <p:cNvSpPr/>
-          <p:nvPr/>
-        </p:nvSpPr>
-        <p:spPr>
-          <a:xfrm>
-            <a:off x="457200" y="1371600"/>
-            <a:ext cx="2697480" cy="2697480"/>
+              <a:rPr lang="en-US" sz="1700" b="1" dirty="0">
+                <a:solidFill>
+                  <a:srgbClr val="2A9D8F"/>
+                </a:solidFill>
+                <a:latin typeface="Calibri" pitchFamily="34" charset="0"/>
+                <a:ea typeface="Calibri" pitchFamily="34" charset="-122"/>
+                <a:cs typeface="Calibri" pitchFamily="34" charset="-120"/>
+              </a:rPr>
+              <a:t>F16</a:t>
+            </a:r>
+            <a:endParaRPr lang="en-US" sz="1700" dirty="0"/>
+          </a:p>
+        </p:txBody>
+      </p:sp>
+      <p:sp>
+        <p:nvSpPr>
+          <p:cNvPr id="21" name="Shape 19"/>
+          <p:cNvSpPr/>
+          <p:nvPr/>
+        </p:nvSpPr>
+        <p:spPr>
+          <a:xfrm>
+            <a:off x="6537960" y="1417320"/>
+            <a:ext cx="2331720" cy="2331720"/>
           </a:xfrm>
           <a:prstGeom prst="rect">
             <a:avLst/>
@@ -3734,14 +3969,14 @@
       </p:sp>
       <p:sp>
         <p:nvSpPr>
-          <p:cNvPr id="7" name="Text 5"/>
-          <p:cNvSpPr/>
-          <p:nvPr/>
-        </p:nvSpPr>
-        <p:spPr>
-          <a:xfrm>
-            <a:off x="457200" y="1371600"/>
-            <a:ext cx="2697480" cy="2697480"/>
+          <p:cNvPr id="22" name="Text 20"/>
+          <p:cNvSpPr/>
+          <p:nvPr/>
+        </p:nvSpPr>
+        <p:spPr>
+          <a:xfrm>
+            <a:off x="6537960" y="1417320"/>
+            <a:ext cx="2331720" cy="2331720"/>
           </a:xfrm>
           <a:prstGeom prst="rect">
             <a:avLst/>
@@ -3773,14 +4008,14 @@
       </p:sp>
       <p:sp>
         <p:nvSpPr>
-          <p:cNvPr id="8" name="Shape 6"/>
-          <p:cNvSpPr/>
-          <p:nvPr/>
-        </p:nvSpPr>
-        <p:spPr>
-          <a:xfrm>
-            <a:off x="3246120" y="1371600"/>
-            <a:ext cx="2697480" cy="2697480"/>
+          <p:cNvPr id="23" name="Shape 21"/>
+          <p:cNvSpPr/>
+          <p:nvPr/>
+        </p:nvSpPr>
+        <p:spPr>
+          <a:xfrm>
+            <a:off x="6537960" y="3840480"/>
+            <a:ext cx="2331720" cy="2331720"/>
           </a:xfrm>
           <a:prstGeom prst="rect">
             <a:avLst/>
@@ -3798,14 +4033,14 @@
       </p:sp>
       <p:sp>
         <p:nvSpPr>
-          <p:cNvPr id="9" name="Text 7"/>
-          <p:cNvSpPr/>
-          <p:nvPr/>
-        </p:nvSpPr>
-        <p:spPr>
-          <a:xfrm>
-            <a:off x="3246120" y="1371600"/>
-            <a:ext cx="2697480" cy="2697480"/>
+          <p:cNvPr id="24" name="Text 22"/>
+          <p:cNvSpPr/>
+          <p:nvPr/>
+        </p:nvSpPr>
+        <p:spPr>
+          <a:xfrm>
+            <a:off x="6537960" y="3840480"/>
+            <a:ext cx="2331720" cy="2331720"/>
           </a:xfrm>
           <a:prstGeom prst="rect">
             <a:avLst/>
@@ -3837,14 +4072,14 @@
       </p:sp>
       <p:sp>
         <p:nvSpPr>
-          <p:cNvPr id="10" name="Text 8"/>
-          <p:cNvSpPr/>
-          <p:nvPr/>
-        </p:nvSpPr>
-        <p:spPr>
-          <a:xfrm>
-            <a:off x="457200" y="4178808"/>
-            <a:ext cx="5486400" cy="365760"/>
+          <p:cNvPr id="25" name="Text 23"/>
+          <p:cNvSpPr/>
+          <p:nvPr/>
+        </p:nvSpPr>
+        <p:spPr>
+          <a:xfrm>
+            <a:off x="6446520" y="6199632"/>
+            <a:ext cx="2514600" cy="457200"/>
           </a:xfrm>
           <a:prstGeom prst="rect">
             <a:avLst/>
@@ -3860,30 +4095,47 @@
               <a:buNone/>
             </a:pPr>
             <a:r>
-              <a:rPr lang="en-US" sz="2000" b="1" dirty="0">
-                <a:solidFill>
-                  <a:srgbClr val="2E2055"/>
-                </a:solidFill>
-                <a:latin typeface="Calibri" pitchFamily="34" charset="0"/>
-                <a:ea typeface="Calibri" pitchFamily="34" charset="-122"/>
-                <a:cs typeface="Calibri" pitchFamily="34" charset="-120"/>
-              </a:rPr>
-              <a:t>Lena</a:t>
-            </a:r>
-            <a:endParaRPr lang="en-US" sz="2000" dirty="0"/>
-          </a:p>
-        </p:txBody>
-      </p:sp>
-      <p:sp>
-        <p:nvSpPr>
-          <p:cNvPr id="11" name="Text 9"/>
-          <p:cNvSpPr/>
-          <p:nvPr/>
-        </p:nvSpPr>
-        <p:spPr>
-          <a:xfrm>
-            <a:off x="457200" y="4572000"/>
-            <a:ext cx="5486400" cy="365760"/>
+              <a:rPr lang="en-US" sz="1300" b="1" dirty="0">
+                <a:solidFill>
+                  <a:srgbClr val="E0457B"/>
+                </a:solidFill>
+                <a:latin typeface="Calibri" pitchFamily="34" charset="0"/>
+                <a:ea typeface="Calibri" pitchFamily="34" charset="-122"/>
+                <a:cs typeface="Calibri" pitchFamily="34" charset="-120"/>
+              </a:rPr>
+              <a:t>CR = ___</a:t>
+            </a:r>
+            <a:endParaRPr lang="en-US" sz="1300" dirty="0"/>
+          </a:p>
+          <a:p>
+            <a:pPr algn="ctr" indent="0" marL="0">
+              <a:buNone/>
+            </a:pPr>
+            <a:r>
+              <a:rPr lang="en-US" sz="1300" dirty="0">
+                <a:solidFill>
+                  <a:srgbClr val="1F1A33"/>
+                </a:solidFill>
+                <a:latin typeface="Calibri" pitchFamily="34" charset="0"/>
+                <a:ea typeface="Calibri" pitchFamily="34" charset="-122"/>
+                <a:cs typeface="Calibri" pitchFamily="34" charset="-120"/>
+              </a:rPr>
+              <a:t>PSNR 29.47 dB   SSIM 0.8539</a:t>
+            </a:r>
+            <a:endParaRPr lang="en-US" sz="1300" dirty="0"/>
+          </a:p>
+        </p:txBody>
+      </p:sp>
+      <p:sp>
+        <p:nvSpPr>
+          <p:cNvPr id="26" name="Text 24"/>
+          <p:cNvSpPr/>
+          <p:nvPr/>
+        </p:nvSpPr>
+        <p:spPr>
+          <a:xfrm>
+            <a:off x="9006840" y="1078992"/>
+            <a:ext cx="2331720" cy="301752"/>
           </a:xfrm>
           <a:prstGeom prst="rect">
             <a:avLst/>
@@ -3899,44 +4151,30 @@
               <a:buNone/>
             </a:pPr>
             <a:r>
-              <a:rPr lang="en-US" sz="1600" b="1" dirty="0">
-                <a:solidFill>
-                  <a:srgbClr val="E0457B"/>
-                </a:solidFill>
-                <a:latin typeface="Calibri" pitchFamily="34" charset="0"/>
-                <a:ea typeface="Calibri" pitchFamily="34" charset="-122"/>
-                <a:cs typeface="Calibri" pitchFamily="34" charset="-120"/>
-              </a:rPr>
-              <a:t>CR = ___</a:t>
-            </a:r>
-            <a:pPr algn="ctr" indent="0" marL="0">
-              <a:buNone/>
-            </a:pPr>
-            <a:r>
-              <a:rPr lang="en-US" sz="1600" dirty="0">
-                <a:solidFill>
-                  <a:srgbClr val="1F1A33"/>
-                </a:solidFill>
-                <a:latin typeface="Calibri" pitchFamily="34" charset="0"/>
-                <a:ea typeface="Calibri" pitchFamily="34" charset="-122"/>
-                <a:cs typeface="Calibri" pitchFamily="34" charset="-120"/>
-              </a:rPr>
-              <a:t>   |   PSNR = 28.91 dB   |   SSIM = 0.7594</a:t>
-            </a:r>
-            <a:endParaRPr lang="en-US" sz="1600" dirty="0"/>
-          </a:p>
-        </p:txBody>
-      </p:sp>
-      <p:sp>
-        <p:nvSpPr>
-          <p:cNvPr id="12" name="Shape 10"/>
-          <p:cNvSpPr/>
-          <p:nvPr/>
-        </p:nvSpPr>
-        <p:spPr>
-          <a:xfrm>
-            <a:off x="6217920" y="1371600"/>
-            <a:ext cx="2697480" cy="2697480"/>
+              <a:rPr lang="en-US" sz="1700" b="1" dirty="0">
+                <a:solidFill>
+                  <a:srgbClr val="2A9D8F"/>
+                </a:solidFill>
+                <a:latin typeface="Calibri" pitchFamily="34" charset="0"/>
+                <a:ea typeface="Calibri" pitchFamily="34" charset="-122"/>
+                <a:cs typeface="Calibri" pitchFamily="34" charset="-120"/>
+              </a:rPr>
+              <a:t>Gold Hill</a:t>
+            </a:r>
+            <a:endParaRPr lang="en-US" sz="1700" dirty="0"/>
+          </a:p>
+        </p:txBody>
+      </p:sp>
+      <p:sp>
+        <p:nvSpPr>
+          <p:cNvPr id="27" name="Shape 25"/>
+          <p:cNvSpPr/>
+          <p:nvPr/>
+        </p:nvSpPr>
+        <p:spPr>
+          <a:xfrm>
+            <a:off x="9006840" y="1417320"/>
+            <a:ext cx="2331720" cy="2331720"/>
           </a:xfrm>
           <a:prstGeom prst="rect">
             <a:avLst/>
@@ -3954,14 +4192,14 @@
       </p:sp>
       <p:sp>
         <p:nvSpPr>
-          <p:cNvPr id="13" name="Text 11"/>
-          <p:cNvSpPr/>
-          <p:nvPr/>
-        </p:nvSpPr>
-        <p:spPr>
-          <a:xfrm>
-            <a:off x="6217920" y="1371600"/>
-            <a:ext cx="2697480" cy="2697480"/>
+          <p:cNvPr id="28" name="Text 26"/>
+          <p:cNvSpPr/>
+          <p:nvPr/>
+        </p:nvSpPr>
+        <p:spPr>
+          <a:xfrm>
+            <a:off x="9006840" y="1417320"/>
+            <a:ext cx="2331720" cy="2331720"/>
           </a:xfrm>
           <a:prstGeom prst="rect">
             <a:avLst/>
@@ -3993,14 +4231,14 @@
       </p:sp>
       <p:sp>
         <p:nvSpPr>
-          <p:cNvPr id="14" name="Shape 12"/>
-          <p:cNvSpPr/>
-          <p:nvPr/>
-        </p:nvSpPr>
-        <p:spPr>
-          <a:xfrm>
-            <a:off x="9006840" y="1371600"/>
-            <a:ext cx="2697480" cy="2697480"/>
+          <p:cNvPr id="29" name="Shape 27"/>
+          <p:cNvSpPr/>
+          <p:nvPr/>
+        </p:nvSpPr>
+        <p:spPr>
+          <a:xfrm>
+            <a:off x="9006840" y="3840480"/>
+            <a:ext cx="2331720" cy="2331720"/>
           </a:xfrm>
           <a:prstGeom prst="rect">
             <a:avLst/>
@@ -4018,14 +4256,14 @@
       </p:sp>
       <p:sp>
         <p:nvSpPr>
-          <p:cNvPr id="15" name="Text 13"/>
-          <p:cNvSpPr/>
-          <p:nvPr/>
-        </p:nvSpPr>
-        <p:spPr>
-          <a:xfrm>
-            <a:off x="9006840" y="1371600"/>
-            <a:ext cx="2697480" cy="2697480"/>
+          <p:cNvPr id="30" name="Text 28"/>
+          <p:cNvSpPr/>
+          <p:nvPr/>
+        </p:nvSpPr>
+        <p:spPr>
+          <a:xfrm>
+            <a:off x="9006840" y="3840480"/>
+            <a:ext cx="2331720" cy="2331720"/>
           </a:xfrm>
           <a:prstGeom prst="rect">
             <a:avLst/>
@@ -4057,14 +4295,14 @@
       </p:sp>
       <p:sp>
         <p:nvSpPr>
-          <p:cNvPr id="16" name="Text 14"/>
-          <p:cNvSpPr/>
-          <p:nvPr/>
-        </p:nvSpPr>
-        <p:spPr>
-          <a:xfrm>
-            <a:off x="6217920" y="4178808"/>
-            <a:ext cx="5486400" cy="365760"/>
+          <p:cNvPr id="31" name="Text 29"/>
+          <p:cNvSpPr/>
+          <p:nvPr/>
+        </p:nvSpPr>
+        <p:spPr>
+          <a:xfrm>
+            <a:off x="8915400" y="6199632"/>
+            <a:ext cx="2514600" cy="457200"/>
           </a:xfrm>
           <a:prstGeom prst="rect">
             <a:avLst/>
@@ -4080,46 +4318,7 @@
               <a:buNone/>
             </a:pPr>
             <a:r>
-              <a:rPr lang="en-US" sz="2000" b="1" dirty="0">
-                <a:solidFill>
-                  <a:srgbClr val="2E2055"/>
-                </a:solidFill>
-                <a:latin typeface="Calibri" pitchFamily="34" charset="0"/>
-                <a:ea typeface="Calibri" pitchFamily="34" charset="-122"/>
-                <a:cs typeface="Calibri" pitchFamily="34" charset="-120"/>
-              </a:rPr>
-              <a:t>Peppers</a:t>
-            </a:r>
-            <a:endParaRPr lang="en-US" sz="2000" dirty="0"/>
-          </a:p>
-        </p:txBody>
-      </p:sp>
-      <p:sp>
-        <p:nvSpPr>
-          <p:cNvPr id="17" name="Text 15"/>
-          <p:cNvSpPr/>
-          <p:nvPr/>
-        </p:nvSpPr>
-        <p:spPr>
-          <a:xfrm>
-            <a:off x="6217920" y="4572000"/>
-            <a:ext cx="5486400" cy="365760"/>
-          </a:xfrm>
-          <a:prstGeom prst="rect">
-            <a:avLst/>
-          </a:prstGeom>
-          <a:noFill/>
-          <a:ln/>
-        </p:spPr>
-        <p:txBody>
-          <a:bodyPr wrap="square" lIns="0" tIns="0" rIns="0" bIns="0" rtlCol="0" anchor="ctr"/>
-          <a:lstStyle/>
-          <a:p>
-            <a:pPr algn="ctr" indent="0" marL="0">
-              <a:buNone/>
-            </a:pPr>
-            <a:r>
-              <a:rPr lang="en-US" sz="1600" b="1" dirty="0">
+              <a:rPr lang="en-US" sz="1300" b="1" dirty="0">
                 <a:solidFill>
                   <a:srgbClr val="E0457B"/>
                 </a:solidFill>
@@ -4129,11 +4328,14 @@
               </a:rPr>
               <a:t>CR = ___</a:t>
             </a:r>
-            <a:pPr algn="ctr" indent="0" marL="0">
-              <a:buNone/>
-            </a:pPr>
-            <a:r>
-              <a:rPr lang="en-US" sz="1600" dirty="0">
+            <a:endParaRPr lang="en-US" sz="1300" dirty="0"/>
+          </a:p>
+          <a:p>
+            <a:pPr algn="ctr" indent="0" marL="0">
+              <a:buNone/>
+            </a:pPr>
+            <a:r>
+              <a:rPr lang="en-US" sz="1300" dirty="0">
                 <a:solidFill>
                   <a:srgbClr val="1F1A33"/>
                 </a:solidFill>
@@ -4141,687 +4343,7 @@
                 <a:ea typeface="Calibri" pitchFamily="34" charset="-122"/>
                 <a:cs typeface="Calibri" pitchFamily="34" charset="-120"/>
               </a:rPr>
-              <a:t>   |   PSNR = 28.35 dB   |   SSIM = 0.6964</a:t>
-            </a:r>
-            <a:endParaRPr lang="en-US" sz="1600" dirty="0"/>
-          </a:p>
-        </p:txBody>
-      </p:sp>
-      <p:sp>
-        <p:nvSpPr>
-          <p:cNvPr id="18" name="Text 16"/>
-          <p:cNvSpPr/>
-          <p:nvPr/>
-        </p:nvSpPr>
-        <p:spPr>
-          <a:xfrm>
-            <a:off x="457200" y="6172200"/>
-            <a:ext cx="11274552" cy="320040"/>
-          </a:xfrm>
-          <a:prstGeom prst="rect">
-            <a:avLst/>
-          </a:prstGeom>
-          <a:noFill/>
-          <a:ln/>
-        </p:spPr>
-        <p:txBody>
-          <a:bodyPr wrap="square" lIns="0" tIns="0" rIns="0" bIns="0" rtlCol="0" anchor="ctr"/>
-          <a:lstStyle/>
-          <a:p>
-            <a:pPr algn="ctr" indent="0" marL="0">
-              <a:buNone/>
-            </a:pPr>
-            <a:r>
-              <a:rPr lang="en-US" sz="1300" i="1" dirty="0">
-                <a:solidFill>
-                  <a:srgbClr val="6B4FA3"/>
-                </a:solidFill>
-                <a:latin typeface="Calibri" pitchFamily="34" charset="0"/>
-                <a:ea typeface="Calibri" pitchFamily="34" charset="-122"/>
-                <a:cs typeface="Calibri" pitchFamily="34" charset="-120"/>
-              </a:rPr>
-              <a:t>Block size 4 × 4, K = 64. Same reconstruction for the sequential and parallel runs.</a:t>
-            </a:r>
-            <a:endParaRPr lang="en-US" sz="1300" dirty="0"/>
-          </a:p>
-        </p:txBody>
-      </p:sp>
-    </p:spTree>
-  </p:cSld>
-  <p:clrMapOvr>
-    <a:masterClrMapping/>
-  </p:clrMapOvr>
-</p:sld>
-</file>
-
-<file path=ppt/slides/slide5.xml><?xml version="1.0" encoding="utf-8"?>
-<p:sld xmlns:a="http://schemas.openxmlformats.org/drawingml/2006/main" xmlns:r="http://schemas.openxmlformats.org/officeDocument/2006/relationships" xmlns:p="http://schemas.openxmlformats.org/presentationml/2006/main">
-  <p:cSld name="Slide 5">
-    <p:bg>
-      <p:bgPr>
-        <a:solidFill>
-          <a:srgbClr val="FFFFFF"/>
-        </a:solidFill>
-      </p:bgPr>
-    </p:bg>
-    <p:spTree>
-      <p:nvGrpSpPr>
-        <p:cNvPr id="1" name=""/>
-        <p:cNvGrpSpPr/>
-        <p:nvPr/>
-      </p:nvGrpSpPr>
-      <p:grpSpPr>
-        <a:xfrm>
-          <a:off x="0" y="0"/>
-          <a:ext cx="0" cy="0"/>
-          <a:chOff x="0" y="0"/>
-          <a:chExt cx="0" cy="0"/>
-        </a:xfrm>
-      </p:grpSpPr>
-      <p:sp>
-        <p:nvSpPr>
-          <p:cNvPr id="2" name="Shape 0"/>
-          <p:cNvSpPr/>
-          <p:nvPr/>
-        </p:nvSpPr>
-        <p:spPr>
-          <a:xfrm>
-            <a:off x="457200" y="320040"/>
-            <a:ext cx="1737360" cy="502920"/>
-          </a:xfrm>
-          <a:prstGeom prst="roundRect">
-            <a:avLst>
-              <a:gd name="adj" fmla="val 18182"/>
-            </a:avLst>
-          </a:prstGeom>
-          <a:solidFill>
-            <a:srgbClr val="2A9D8F"/>
-          </a:solidFill>
-          <a:ln w="12700">
-            <a:solidFill>
-              <a:srgbClr val="2A9D8F"/>
-            </a:solidFill>
-            <a:prstDash val="solid"/>
-          </a:ln>
-        </p:spPr>
-      </p:sp>
-      <p:sp>
-        <p:nvSpPr>
-          <p:cNvPr id="3" name="Text 1"/>
-          <p:cNvSpPr/>
-          <p:nvPr/>
-        </p:nvSpPr>
-        <p:spPr>
-          <a:xfrm>
-            <a:off x="457200" y="320040"/>
-            <a:ext cx="1737360" cy="502920"/>
-          </a:xfrm>
-          <a:prstGeom prst="rect">
-            <a:avLst/>
-          </a:prstGeom>
-          <a:noFill/>
-          <a:ln/>
-        </p:spPr>
-        <p:txBody>
-          <a:bodyPr wrap="square" lIns="0" tIns="0" rIns="0" bIns="0" rtlCol="0" anchor="ctr"/>
-          <a:lstStyle/>
-          <a:p>
-            <a:pPr algn="ctr" indent="0" marL="0">
-              <a:buNone/>
-            </a:pPr>
-            <a:r>
-              <a:rPr lang="en-US" sz="1800" b="1" dirty="0">
-                <a:solidFill>
-                  <a:srgbClr val="FFFFFF"/>
-                </a:solidFill>
-                <a:latin typeface="Calibri" pitchFamily="34" charset="0"/>
-                <a:ea typeface="Calibri" pitchFamily="34" charset="-122"/>
-                <a:cs typeface="Calibri" pitchFamily="34" charset="-120"/>
-              </a:rPr>
-              <a:t>Results</a:t>
-            </a:r>
-            <a:endParaRPr lang="en-US" sz="1800" dirty="0"/>
-          </a:p>
-        </p:txBody>
-      </p:sp>
-      <p:sp>
-        <p:nvSpPr>
-          <p:cNvPr id="4" name="Text 2"/>
-          <p:cNvSpPr/>
-          <p:nvPr/>
-        </p:nvSpPr>
-        <p:spPr>
-          <a:xfrm>
-            <a:off x="2377440" y="274320"/>
-            <a:ext cx="9326880" cy="594360"/>
-          </a:xfrm>
-          <a:prstGeom prst="rect">
-            <a:avLst/>
-          </a:prstGeom>
-          <a:noFill/>
-          <a:ln/>
-        </p:spPr>
-        <p:txBody>
-          <a:bodyPr wrap="square" lIns="0" tIns="0" rIns="0" bIns="0" rtlCol="0" anchor="ctr"/>
-          <a:lstStyle/>
-          <a:p>
-            <a:pPr indent="0" marL="0">
-              <a:buNone/>
-            </a:pPr>
-            <a:r>
-              <a:rPr lang="en-US" sz="2800" b="1" dirty="0">
-                <a:solidFill>
-                  <a:srgbClr val="2E2055"/>
-                </a:solidFill>
-                <a:latin typeface="Cambria" pitchFamily="34" charset="0"/>
-                <a:ea typeface="Cambria" pitchFamily="34" charset="-122"/>
-                <a:cs typeface="Cambria" pitchFamily="34" charset="-120"/>
-              </a:rPr>
-              <a:t>Original vs Reconstructed: Color</a:t>
-            </a:r>
-            <a:endParaRPr lang="en-US" sz="2800" dirty="0"/>
-          </a:p>
-        </p:txBody>
-      </p:sp>
-      <p:sp>
-        <p:nvSpPr>
-          <p:cNvPr id="5" name="Shape 3"/>
-          <p:cNvSpPr/>
-          <p:nvPr/>
-        </p:nvSpPr>
-        <p:spPr>
-          <a:xfrm>
-            <a:off x="457200" y="960120"/>
-            <a:ext cx="11274552" cy="36576"/>
-          </a:xfrm>
-          <a:prstGeom prst="rect">
-            <a:avLst/>
-          </a:prstGeom>
-          <a:solidFill>
-            <a:srgbClr val="2A9D8F"/>
-          </a:solidFill>
-          <a:ln w="12700">
-            <a:solidFill>
-              <a:srgbClr val="2A9D8F"/>
-            </a:solidFill>
-            <a:prstDash val="solid"/>
-          </a:ln>
-        </p:spPr>
-      </p:sp>
-      <p:sp>
-        <p:nvSpPr>
-          <p:cNvPr id="6" name="Shape 4"/>
-          <p:cNvSpPr/>
-          <p:nvPr/>
-        </p:nvSpPr>
-        <p:spPr>
-          <a:xfrm>
-            <a:off x="457200" y="1371600"/>
-            <a:ext cx="2697480" cy="2697480"/>
-          </a:xfrm>
-          <a:prstGeom prst="rect">
-            <a:avLst/>
-          </a:prstGeom>
-          <a:solidFill>
-            <a:srgbClr val="F5F1FB"/>
-          </a:solidFill>
-          <a:ln w="19050">
-            <a:solidFill>
-              <a:srgbClr val="6B4FA3"/>
-            </a:solidFill>
-            <a:prstDash val="dash"/>
-          </a:ln>
-        </p:spPr>
-      </p:sp>
-      <p:sp>
-        <p:nvSpPr>
-          <p:cNvPr id="7" name="Text 5"/>
-          <p:cNvSpPr/>
-          <p:nvPr/>
-        </p:nvSpPr>
-        <p:spPr>
-          <a:xfrm>
-            <a:off x="457200" y="1371600"/>
-            <a:ext cx="2697480" cy="2697480"/>
-          </a:xfrm>
-          <a:prstGeom prst="rect">
-            <a:avLst/>
-          </a:prstGeom>
-          <a:noFill/>
-          <a:ln/>
-        </p:spPr>
-        <p:txBody>
-          <a:bodyPr wrap="square" lIns="1270" tIns="1270" rIns="1270" bIns="1270" rtlCol="0" anchor="ctr"/>
-          <a:lstStyle/>
-          <a:p>
-            <a:pPr algn="ctr" indent="0" marL="0">
-              <a:buNone/>
-            </a:pPr>
-            <a:r>
-              <a:rPr lang="en-US" sz="1400" i="1" dirty="0">
-                <a:solidFill>
-                  <a:srgbClr val="6B4FA3"/>
-                </a:solidFill>
-                <a:latin typeface="Calibri" pitchFamily="34" charset="0"/>
-                <a:ea typeface="Calibri" pitchFamily="34" charset="-122"/>
-                <a:cs typeface="Calibri" pitchFamily="34" charset="-120"/>
-              </a:rPr>
-              <a:t>Original</a:t>
-            </a:r>
-            <a:endParaRPr lang="en-US" sz="1400" dirty="0"/>
-          </a:p>
-        </p:txBody>
-      </p:sp>
-      <p:sp>
-        <p:nvSpPr>
-          <p:cNvPr id="8" name="Shape 6"/>
-          <p:cNvSpPr/>
-          <p:nvPr/>
-        </p:nvSpPr>
-        <p:spPr>
-          <a:xfrm>
-            <a:off x="3246120" y="1371600"/>
-            <a:ext cx="2697480" cy="2697480"/>
-          </a:xfrm>
-          <a:prstGeom prst="rect">
-            <a:avLst/>
-          </a:prstGeom>
-          <a:solidFill>
-            <a:srgbClr val="F5F1FB"/>
-          </a:solidFill>
-          <a:ln w="19050">
-            <a:solidFill>
-              <a:srgbClr val="6B4FA3"/>
-            </a:solidFill>
-            <a:prstDash val="dash"/>
-          </a:ln>
-        </p:spPr>
-      </p:sp>
-      <p:sp>
-        <p:nvSpPr>
-          <p:cNvPr id="9" name="Text 7"/>
-          <p:cNvSpPr/>
-          <p:nvPr/>
-        </p:nvSpPr>
-        <p:spPr>
-          <a:xfrm>
-            <a:off x="3246120" y="1371600"/>
-            <a:ext cx="2697480" cy="2697480"/>
-          </a:xfrm>
-          <a:prstGeom prst="rect">
-            <a:avLst/>
-          </a:prstGeom>
-          <a:noFill/>
-          <a:ln/>
-        </p:spPr>
-        <p:txBody>
-          <a:bodyPr wrap="square" lIns="1270" tIns="1270" rIns="1270" bIns="1270" rtlCol="0" anchor="ctr"/>
-          <a:lstStyle/>
-          <a:p>
-            <a:pPr algn="ctr" indent="0" marL="0">
-              <a:buNone/>
-            </a:pPr>
-            <a:r>
-              <a:rPr lang="en-US" sz="1400" i="1" dirty="0">
-                <a:solidFill>
-                  <a:srgbClr val="6B4FA3"/>
-                </a:solidFill>
-                <a:latin typeface="Calibri" pitchFamily="34" charset="0"/>
-                <a:ea typeface="Calibri" pitchFamily="34" charset="-122"/>
-                <a:cs typeface="Calibri" pitchFamily="34" charset="-120"/>
-              </a:rPr>
-              <a:t>Reconstructed</a:t>
-            </a:r>
-            <a:endParaRPr lang="en-US" sz="1400" dirty="0"/>
-          </a:p>
-        </p:txBody>
-      </p:sp>
-      <p:sp>
-        <p:nvSpPr>
-          <p:cNvPr id="10" name="Text 8"/>
-          <p:cNvSpPr/>
-          <p:nvPr/>
-        </p:nvSpPr>
-        <p:spPr>
-          <a:xfrm>
-            <a:off x="457200" y="4178808"/>
-            <a:ext cx="5486400" cy="365760"/>
-          </a:xfrm>
-          <a:prstGeom prst="rect">
-            <a:avLst/>
-          </a:prstGeom>
-          <a:noFill/>
-          <a:ln/>
-        </p:spPr>
-        <p:txBody>
-          <a:bodyPr wrap="square" lIns="0" tIns="0" rIns="0" bIns="0" rtlCol="0" anchor="ctr"/>
-          <a:lstStyle/>
-          <a:p>
-            <a:pPr algn="ctr" indent="0" marL="0">
-              <a:buNone/>
-            </a:pPr>
-            <a:r>
-              <a:rPr lang="en-US" sz="2000" b="1" dirty="0">
-                <a:solidFill>
-                  <a:srgbClr val="2E2055"/>
-                </a:solidFill>
-                <a:latin typeface="Calibri" pitchFamily="34" charset="0"/>
-                <a:ea typeface="Calibri" pitchFamily="34" charset="-122"/>
-                <a:cs typeface="Calibri" pitchFamily="34" charset="-120"/>
-              </a:rPr>
-              <a:t>F16</a:t>
-            </a:r>
-            <a:endParaRPr lang="en-US" sz="2000" dirty="0"/>
-          </a:p>
-        </p:txBody>
-      </p:sp>
-      <p:sp>
-        <p:nvSpPr>
-          <p:cNvPr id="11" name="Text 9"/>
-          <p:cNvSpPr/>
-          <p:nvPr/>
-        </p:nvSpPr>
-        <p:spPr>
-          <a:xfrm>
-            <a:off x="457200" y="4572000"/>
-            <a:ext cx="5486400" cy="365760"/>
-          </a:xfrm>
-          <a:prstGeom prst="rect">
-            <a:avLst/>
-          </a:prstGeom>
-          <a:noFill/>
-          <a:ln/>
-        </p:spPr>
-        <p:txBody>
-          <a:bodyPr wrap="square" lIns="0" tIns="0" rIns="0" bIns="0" rtlCol="0" anchor="ctr"/>
-          <a:lstStyle/>
-          <a:p>
-            <a:pPr algn="ctr" indent="0" marL="0">
-              <a:buNone/>
-            </a:pPr>
-            <a:r>
-              <a:rPr lang="en-US" sz="1600" b="1" dirty="0">
-                <a:solidFill>
-                  <a:srgbClr val="E0457B"/>
-                </a:solidFill>
-                <a:latin typeface="Calibri" pitchFamily="34" charset="0"/>
-                <a:ea typeface="Calibri" pitchFamily="34" charset="-122"/>
-                <a:cs typeface="Calibri" pitchFamily="34" charset="-120"/>
-              </a:rPr>
-              <a:t>CR = ___</a:t>
-            </a:r>
-            <a:pPr algn="ctr" indent="0" marL="0">
-              <a:buNone/>
-            </a:pPr>
-            <a:r>
-              <a:rPr lang="en-US" sz="1600" dirty="0">
-                <a:solidFill>
-                  <a:srgbClr val="1F1A33"/>
-                </a:solidFill>
-                <a:latin typeface="Calibri" pitchFamily="34" charset="0"/>
-                <a:ea typeface="Calibri" pitchFamily="34" charset="-122"/>
-                <a:cs typeface="Calibri" pitchFamily="34" charset="-120"/>
-              </a:rPr>
-              <a:t>   |   PSNR = 29.47 dB   |   SSIM = 0.8539</a:t>
-            </a:r>
-            <a:endParaRPr lang="en-US" sz="1600" dirty="0"/>
-          </a:p>
-        </p:txBody>
-      </p:sp>
-      <p:sp>
-        <p:nvSpPr>
-          <p:cNvPr id="12" name="Shape 10"/>
-          <p:cNvSpPr/>
-          <p:nvPr/>
-        </p:nvSpPr>
-        <p:spPr>
-          <a:xfrm>
-            <a:off x="6217920" y="1371600"/>
-            <a:ext cx="2697480" cy="2697480"/>
-          </a:xfrm>
-          <a:prstGeom prst="rect">
-            <a:avLst/>
-          </a:prstGeom>
-          <a:solidFill>
-            <a:srgbClr val="F5F1FB"/>
-          </a:solidFill>
-          <a:ln w="19050">
-            <a:solidFill>
-              <a:srgbClr val="6B4FA3"/>
-            </a:solidFill>
-            <a:prstDash val="dash"/>
-          </a:ln>
-        </p:spPr>
-      </p:sp>
-      <p:sp>
-        <p:nvSpPr>
-          <p:cNvPr id="13" name="Text 11"/>
-          <p:cNvSpPr/>
-          <p:nvPr/>
-        </p:nvSpPr>
-        <p:spPr>
-          <a:xfrm>
-            <a:off x="6217920" y="1371600"/>
-            <a:ext cx="2697480" cy="2697480"/>
-          </a:xfrm>
-          <a:prstGeom prst="rect">
-            <a:avLst/>
-          </a:prstGeom>
-          <a:noFill/>
-          <a:ln/>
-        </p:spPr>
-        <p:txBody>
-          <a:bodyPr wrap="square" lIns="1270" tIns="1270" rIns="1270" bIns="1270" rtlCol="0" anchor="ctr"/>
-          <a:lstStyle/>
-          <a:p>
-            <a:pPr algn="ctr" indent="0" marL="0">
-              <a:buNone/>
-            </a:pPr>
-            <a:r>
-              <a:rPr lang="en-US" sz="1400" i="1" dirty="0">
-                <a:solidFill>
-                  <a:srgbClr val="6B4FA3"/>
-                </a:solidFill>
-                <a:latin typeface="Calibri" pitchFamily="34" charset="0"/>
-                <a:ea typeface="Calibri" pitchFamily="34" charset="-122"/>
-                <a:cs typeface="Calibri" pitchFamily="34" charset="-120"/>
-              </a:rPr>
-              <a:t>Original</a:t>
-            </a:r>
-            <a:endParaRPr lang="en-US" sz="1400" dirty="0"/>
-          </a:p>
-        </p:txBody>
-      </p:sp>
-      <p:sp>
-        <p:nvSpPr>
-          <p:cNvPr id="14" name="Shape 12"/>
-          <p:cNvSpPr/>
-          <p:nvPr/>
-        </p:nvSpPr>
-        <p:spPr>
-          <a:xfrm>
-            <a:off x="9006840" y="1371600"/>
-            <a:ext cx="2697480" cy="2697480"/>
-          </a:xfrm>
-          <a:prstGeom prst="rect">
-            <a:avLst/>
-          </a:prstGeom>
-          <a:solidFill>
-            <a:srgbClr val="F5F1FB"/>
-          </a:solidFill>
-          <a:ln w="19050">
-            <a:solidFill>
-              <a:srgbClr val="6B4FA3"/>
-            </a:solidFill>
-            <a:prstDash val="dash"/>
-          </a:ln>
-        </p:spPr>
-      </p:sp>
-      <p:sp>
-        <p:nvSpPr>
-          <p:cNvPr id="15" name="Text 13"/>
-          <p:cNvSpPr/>
-          <p:nvPr/>
-        </p:nvSpPr>
-        <p:spPr>
-          <a:xfrm>
-            <a:off x="9006840" y="1371600"/>
-            <a:ext cx="2697480" cy="2697480"/>
-          </a:xfrm>
-          <a:prstGeom prst="rect">
-            <a:avLst/>
-          </a:prstGeom>
-          <a:noFill/>
-          <a:ln/>
-        </p:spPr>
-        <p:txBody>
-          <a:bodyPr wrap="square" lIns="1270" tIns="1270" rIns="1270" bIns="1270" rtlCol="0" anchor="ctr"/>
-          <a:lstStyle/>
-          <a:p>
-            <a:pPr algn="ctr" indent="0" marL="0">
-              <a:buNone/>
-            </a:pPr>
-            <a:r>
-              <a:rPr lang="en-US" sz="1400" i="1" dirty="0">
-                <a:solidFill>
-                  <a:srgbClr val="6B4FA3"/>
-                </a:solidFill>
-                <a:latin typeface="Calibri" pitchFamily="34" charset="0"/>
-                <a:ea typeface="Calibri" pitchFamily="34" charset="-122"/>
-                <a:cs typeface="Calibri" pitchFamily="34" charset="-120"/>
-              </a:rPr>
-              <a:t>Reconstructed</a:t>
-            </a:r>
-            <a:endParaRPr lang="en-US" sz="1400" dirty="0"/>
-          </a:p>
-        </p:txBody>
-      </p:sp>
-      <p:sp>
-        <p:nvSpPr>
-          <p:cNvPr id="16" name="Text 14"/>
-          <p:cNvSpPr/>
-          <p:nvPr/>
-        </p:nvSpPr>
-        <p:spPr>
-          <a:xfrm>
-            <a:off x="6217920" y="4178808"/>
-            <a:ext cx="5486400" cy="365760"/>
-          </a:xfrm>
-          <a:prstGeom prst="rect">
-            <a:avLst/>
-          </a:prstGeom>
-          <a:noFill/>
-          <a:ln/>
-        </p:spPr>
-        <p:txBody>
-          <a:bodyPr wrap="square" lIns="0" tIns="0" rIns="0" bIns="0" rtlCol="0" anchor="ctr"/>
-          <a:lstStyle/>
-          <a:p>
-            <a:pPr algn="ctr" indent="0" marL="0">
-              <a:buNone/>
-            </a:pPr>
-            <a:r>
-              <a:rPr lang="en-US" sz="2000" b="1" dirty="0">
-                <a:solidFill>
-                  <a:srgbClr val="2E2055"/>
-                </a:solidFill>
-                <a:latin typeface="Calibri" pitchFamily="34" charset="0"/>
-                <a:ea typeface="Calibri" pitchFamily="34" charset="-122"/>
-                <a:cs typeface="Calibri" pitchFamily="34" charset="-120"/>
-              </a:rPr>
-              <a:t>Gold Hill</a:t>
-            </a:r>
-            <a:endParaRPr lang="en-US" sz="2000" dirty="0"/>
-          </a:p>
-        </p:txBody>
-      </p:sp>
-      <p:sp>
-        <p:nvSpPr>
-          <p:cNvPr id="17" name="Text 15"/>
-          <p:cNvSpPr/>
-          <p:nvPr/>
-        </p:nvSpPr>
-        <p:spPr>
-          <a:xfrm>
-            <a:off x="6217920" y="4572000"/>
-            <a:ext cx="5486400" cy="365760"/>
-          </a:xfrm>
-          <a:prstGeom prst="rect">
-            <a:avLst/>
-          </a:prstGeom>
-          <a:noFill/>
-          <a:ln/>
-        </p:spPr>
-        <p:txBody>
-          <a:bodyPr wrap="square" lIns="0" tIns="0" rIns="0" bIns="0" rtlCol="0" anchor="ctr"/>
-          <a:lstStyle/>
-          <a:p>
-            <a:pPr algn="ctr" indent="0" marL="0">
-              <a:buNone/>
-            </a:pPr>
-            <a:r>
-              <a:rPr lang="en-US" sz="1600" b="1" dirty="0">
-                <a:solidFill>
-                  <a:srgbClr val="E0457B"/>
-                </a:solidFill>
-                <a:latin typeface="Calibri" pitchFamily="34" charset="0"/>
-                <a:ea typeface="Calibri" pitchFamily="34" charset="-122"/>
-                <a:cs typeface="Calibri" pitchFamily="34" charset="-120"/>
-              </a:rPr>
-              <a:t>CR = ___</a:t>
-            </a:r>
-            <a:pPr algn="ctr" indent="0" marL="0">
-              <a:buNone/>
-            </a:pPr>
-            <a:r>
-              <a:rPr lang="en-US" sz="1600" dirty="0">
-                <a:solidFill>
-                  <a:srgbClr val="1F1A33"/>
-                </a:solidFill>
-                <a:latin typeface="Calibri" pitchFamily="34" charset="0"/>
-                <a:ea typeface="Calibri" pitchFamily="34" charset="-122"/>
-                <a:cs typeface="Calibri" pitchFamily="34" charset="-120"/>
-              </a:rPr>
-              <a:t>   |   PSNR = 28.45 dB   |   SSIM = 0.7520</a:t>
-            </a:r>
-            <a:endParaRPr lang="en-US" sz="1600" dirty="0"/>
-          </a:p>
-        </p:txBody>
-      </p:sp>
-      <p:sp>
-        <p:nvSpPr>
-          <p:cNvPr id="18" name="Text 16"/>
-          <p:cNvSpPr/>
-          <p:nvPr/>
-        </p:nvSpPr>
-        <p:spPr>
-          <a:xfrm>
-            <a:off x="457200" y="6172200"/>
-            <a:ext cx="11274552" cy="320040"/>
-          </a:xfrm>
-          <a:prstGeom prst="rect">
-            <a:avLst/>
-          </a:prstGeom>
-          <a:noFill/>
-          <a:ln/>
-        </p:spPr>
-        <p:txBody>
-          <a:bodyPr wrap="square" lIns="0" tIns="0" rIns="0" bIns="0" rtlCol="0" anchor="ctr"/>
-          <a:lstStyle/>
-          <a:p>
-            <a:pPr algn="ctr" indent="0" marL="0">
-              <a:buNone/>
-            </a:pPr>
-            <a:r>
-              <a:rPr lang="en-US" sz="1300" i="1" dirty="0">
-                <a:solidFill>
-                  <a:srgbClr val="6B4FA3"/>
-                </a:solidFill>
-                <a:latin typeface="Calibri" pitchFamily="34" charset="0"/>
-                <a:ea typeface="Calibri" pitchFamily="34" charset="-122"/>
-                <a:cs typeface="Calibri" pitchFamily="34" charset="-120"/>
-              </a:rPr>
-              <a:t>Block size 4 × 4, K = 64. Same reconstruction for the sequential and parallel runs.</a:t>
+              <a:t>PSNR 28.45 dB   SSIM 0.7520</a:t>
             </a:r>
             <a:endParaRPr lang="en-US" sz="1300" dirty="0"/>
           </a:p>

</xml_diff>